<commit_message>
Wire real Mivada logos into the Editorial concept
- Move the supplied logo kit to design-system/assets/logos/ and document it
  (variants + per-background placement; templates fall back to the M chip).
- Editorial 02 now uses the real art on the right pages:
  * deck cover & closing  -> 2C-OnBlack wordmark (coral M + white text)
  * deck content slides    -> small M mark, top-left (Melon on light, White on black)
  * document masthead      -> Master wordmark (coral M + ink text)
  * document footer        -> small Melon M mark
- Implemented in build_pptx.py (_logo helper), presentation.html (.logo + ::before),
  document.html, and build_docx.js (ImageRun); pptx/docx regenerated, docx validates.

https://claude.ai/code/session_018CuPeTbPKyC5roqRrfQGYh
</commit_message>
<xml_diff>
--- a/design-system/02-editorial/editorial.pptx
+++ b/design-system/02-editorial/editorial.pptx
@@ -3103,61 +3103,30 @@
         <p:nvPr/>
       </p:nvGrpSpPr>
       <p:grpSpPr/>
-      <p:sp>
-        <p:nvSpPr>
-          <p:cNvPr id="2" name="Rounded Rectangle 1"/>
-          <p:cNvSpPr/>
-          <p:nvPr/>
-        </p:nvSpPr>
-        <p:spPr>
-          <a:xfrm>
-            <a:off x="877824" y="658368"/>
-            <a:ext cx="566928" cy="566928"/>
-          </a:xfrm>
-          <a:prstGeom prst="roundRect">
-            <a:avLst>
-              <a:gd name="adj" fmla="val 20000"/>
-            </a:avLst>
-          </a:prstGeom>
-          <a:solidFill>
-            <a:srgbClr val="EA493F"/>
-          </a:solidFill>
-          <a:ln>
-            <a:noFill/>
-          </a:ln>
-          <a:effectLst/>
-        </p:spPr>
-        <p:style>
-          <a:lnRef idx="1">
-            <a:schemeClr val="accent1"/>
-          </a:lnRef>
-          <a:fillRef idx="3">
-            <a:schemeClr val="accent1"/>
-          </a:fillRef>
-          <a:effectRef idx="2">
-            <a:schemeClr val="accent1"/>
-          </a:effectRef>
-          <a:fontRef idx="minor">
-            <a:schemeClr val="lt1"/>
-          </a:fontRef>
-        </p:style>
-        <p:txBody>
-          <a:bodyPr rtlCol="0" anchor="ctr" wrap="square" lIns="0" rIns="0" tIns="0" bIns="0"/>
-          <a:lstStyle/>
-          <a:p>
-            <a:pPr algn="ctr"/>
-            <a:r>
-              <a:rPr sz="2852" b="1" i="0" lang="en-AU" spc="-114">
-                <a:solidFill>
-                  <a:srgbClr val="FFFFFF"/>
-                </a:solidFill>
-                <a:latin typeface="Inter"/>
-              </a:rPr>
-              <a:t>M</a:t>
-            </a:r>
-          </a:p>
-        </p:txBody>
-      </p:sp>
+      <p:pic>
+        <p:nvPicPr>
+          <p:cNvPr id="2" name="Picture 1" descr="Mivada_Logo_2C_OnBlack_RGB_L.png"/>
+          <p:cNvPicPr>
+            <a:picLocks noChangeAspect="1"/>
+          </p:cNvPicPr>
+          <p:nvPr/>
+        </p:nvPicPr>
+        <p:blipFill>
+          <a:blip r:embed="rId2"/>
+          <a:stretch>
+            <a:fillRect/>
+          </a:stretch>
+        </p:blipFill>
+        <p:spPr>
+          <a:xfrm>
+            <a:off x="877824" y="749808"/>
+            <a:ext cx="2531685" cy="384048"/>
+          </a:xfrm>
+          <a:prstGeom prst="rect">
+            <a:avLst/>
+          </a:prstGeom>
+        </p:spPr>
+      </p:pic>
       <p:sp>
         <p:nvSpPr>
           <p:cNvPr id="3" name="TextBox 2"/>
@@ -3166,8 +3135,8 @@
         </p:nvSpPr>
         <p:spPr>
           <a:xfrm>
-            <a:off x="1591056" y="658368"/>
-            <a:ext cx="4572000" cy="566928"/>
+            <a:off x="877824" y="2331720"/>
+            <a:ext cx="7315200" cy="320040"/>
           </a:xfrm>
           <a:prstGeom prst="rect">
             <a:avLst/>
@@ -3175,7 +3144,7 @@
           <a:noFill/>
         </p:spPr>
         <p:txBody>
-          <a:bodyPr wrap="square" anchor="ctr" lIns="0" rIns="0" tIns="0" bIns="0"/>
+          <a:bodyPr wrap="square" anchor="t" lIns="0" rIns="0" tIns="0" bIns="0"/>
           <a:lstStyle/>
           <a:p>
             <a:pPr algn="l">
@@ -3190,13 +3159,13 @@
               </a:spcAft>
             </a:pPr>
             <a:r>
-              <a:rPr sz="2200" b="1" i="0" lang="en-AU" spc="-65">
-                <a:solidFill>
-                  <a:srgbClr val="FFFFFF"/>
-                </a:solidFill>
-                <a:latin typeface="Inter"/>
-              </a:rPr>
-              <a:t>Mivada</a:t>
+              <a:rPr sz="1200" b="1" i="0" lang="en-AU" spc="192" cap="all">
+                <a:solidFill>
+                  <a:srgbClr val="EA493F"/>
+                </a:solidFill>
+                <a:latin typeface="Inter"/>
+              </a:rPr>
+              <a:t>CAPABILITY OVERVIEW · 2026</a:t>
             </a:r>
           </a:p>
         </p:txBody>
@@ -3209,49 +3178,6 @@
         </p:nvSpPr>
         <p:spPr>
           <a:xfrm>
-            <a:off x="877824" y="2331720"/>
-            <a:ext cx="7315200" cy="320040"/>
-          </a:xfrm>
-          <a:prstGeom prst="rect">
-            <a:avLst/>
-          </a:prstGeom>
-          <a:noFill/>
-        </p:spPr>
-        <p:txBody>
-          <a:bodyPr wrap="square" anchor="t" lIns="0" rIns="0" tIns="0" bIns="0"/>
-          <a:lstStyle/>
-          <a:p>
-            <a:pPr algn="l">
-              <a:lnSpc>
-                <a:spcPct val="100000"/>
-              </a:lnSpc>
-              <a:spcBef>
-                <a:spcPts val="0"/>
-              </a:spcBef>
-              <a:spcAft>
-                <a:spcPts val="0"/>
-              </a:spcAft>
-            </a:pPr>
-            <a:r>
-              <a:rPr sz="1200" b="1" i="0" lang="en-AU" spc="192" cap="all">
-                <a:solidFill>
-                  <a:srgbClr val="EA493F"/>
-                </a:solidFill>
-                <a:latin typeface="Inter"/>
-              </a:rPr>
-              <a:t>CAPABILITY OVERVIEW · 2026</a:t>
-            </a:r>
-          </a:p>
-        </p:txBody>
-      </p:sp>
-      <p:sp>
-        <p:nvSpPr>
-          <p:cNvPr id="5" name="TextBox 4"/>
-          <p:cNvSpPr txBox="1"/>
-          <p:nvPr/>
-        </p:nvSpPr>
-        <p:spPr>
-          <a:xfrm>
             <a:off x="841248" y="2697480"/>
             <a:ext cx="10424160" cy="3108960"/>
           </a:xfrm>
@@ -3320,7 +3246,7 @@
       </p:sp>
       <p:cxnSp>
         <p:nvCxnSpPr>
-          <p:cNvPr id="6" name="Connector 5"/>
+          <p:cNvPr id="5" name="Connector 4"/>
           <p:cNvCxnSpPr/>
           <p:nvPr/>
         </p:nvCxnSpPr>
@@ -3356,7 +3282,7 @@
       </p:cxnSp>
       <p:sp>
         <p:nvSpPr>
-          <p:cNvPr id="7" name="TextBox 6"/>
+          <p:cNvPr id="6" name="TextBox 5"/>
           <p:cNvSpPr txBox="1"/>
           <p:nvPr/>
         </p:nvSpPr>
@@ -3399,7 +3325,7 @@
       </p:sp>
       <p:sp>
         <p:nvSpPr>
-          <p:cNvPr id="8" name="TextBox 7"/>
+          <p:cNvPr id="7" name="TextBox 6"/>
           <p:cNvSpPr txBox="1"/>
           <p:nvPr/>
         </p:nvSpPr>
@@ -3466,9 +3392,33 @@
         <p:nvPr/>
       </p:nvGrpSpPr>
       <p:grpSpPr/>
-      <p:sp>
-        <p:nvSpPr>
-          <p:cNvPr id="2" name="TextBox 1"/>
+      <p:pic>
+        <p:nvPicPr>
+          <p:cNvPr id="2" name="Picture 1" descr="Mivada_Icon_Melon_RGB_L.png"/>
+          <p:cNvPicPr>
+            <a:picLocks noChangeAspect="1"/>
+          </p:cNvPicPr>
+          <p:nvPr/>
+        </p:nvPicPr>
+        <p:blipFill>
+          <a:blip r:embed="rId2"/>
+          <a:stretch>
+            <a:fillRect/>
+          </a:stretch>
+        </p:blipFill>
+        <p:spPr>
+          <a:xfrm>
+            <a:off x="877824" y="457200"/>
+            <a:ext cx="402032" cy="237744"/>
+          </a:xfrm>
+          <a:prstGeom prst="rect">
+            <a:avLst/>
+          </a:prstGeom>
+        </p:spPr>
+      </p:pic>
+      <p:sp>
+        <p:nvSpPr>
+          <p:cNvPr id="3" name="TextBox 2"/>
           <p:cNvSpPr txBox="1"/>
           <p:nvPr/>
         </p:nvSpPr>
@@ -3511,7 +3461,7 @@
       </p:sp>
       <p:sp>
         <p:nvSpPr>
-          <p:cNvPr id="3" name="TextBox 2"/>
+          <p:cNvPr id="4" name="TextBox 3"/>
           <p:cNvSpPr txBox="1"/>
           <p:nvPr/>
         </p:nvSpPr>
@@ -3554,7 +3504,7 @@
       </p:sp>
       <p:sp>
         <p:nvSpPr>
-          <p:cNvPr id="4" name="TextBox 3"/>
+          <p:cNvPr id="5" name="TextBox 4"/>
           <p:cNvSpPr txBox="1"/>
           <p:nvPr/>
         </p:nvSpPr>
@@ -3606,7 +3556,7 @@
       </p:sp>
       <p:sp>
         <p:nvSpPr>
-          <p:cNvPr id="5" name="TextBox 4"/>
+          <p:cNvPr id="6" name="TextBox 5"/>
           <p:cNvSpPr txBox="1"/>
           <p:nvPr/>
         </p:nvSpPr>
@@ -3649,7 +3599,7 @@
       </p:sp>
       <p:cxnSp>
         <p:nvCxnSpPr>
-          <p:cNvPr id="6" name="Connector 5"/>
+          <p:cNvPr id="7" name="Connector 6"/>
           <p:cNvCxnSpPr/>
           <p:nvPr/>
         </p:nvCxnSpPr>
@@ -3685,7 +3635,7 @@
       </p:cxnSp>
       <p:sp>
         <p:nvSpPr>
-          <p:cNvPr id="7" name="TextBox 6"/>
+          <p:cNvPr id="8" name="TextBox 7"/>
           <p:cNvSpPr txBox="1"/>
           <p:nvPr/>
         </p:nvSpPr>
@@ -3728,7 +3678,7 @@
       </p:sp>
       <p:sp>
         <p:nvSpPr>
-          <p:cNvPr id="8" name="TextBox 7"/>
+          <p:cNvPr id="9" name="TextBox 8"/>
           <p:cNvSpPr txBox="1"/>
           <p:nvPr/>
         </p:nvSpPr>
@@ -3771,7 +3721,7 @@
       </p:sp>
       <p:cxnSp>
         <p:nvCxnSpPr>
-          <p:cNvPr id="9" name="Connector 8"/>
+          <p:cNvPr id="10" name="Connector 9"/>
           <p:cNvCxnSpPr/>
           <p:nvPr/>
         </p:nvCxnSpPr>
@@ -3807,7 +3757,7 @@
       </p:cxnSp>
       <p:sp>
         <p:nvSpPr>
-          <p:cNvPr id="10" name="TextBox 9"/>
+          <p:cNvPr id="11" name="TextBox 10"/>
           <p:cNvSpPr txBox="1"/>
           <p:nvPr/>
         </p:nvSpPr>
@@ -3859,7 +3809,7 @@
       </p:sp>
       <p:sp>
         <p:nvSpPr>
-          <p:cNvPr id="11" name="TextBox 10"/>
+          <p:cNvPr id="12" name="TextBox 11"/>
           <p:cNvSpPr txBox="1"/>
           <p:nvPr/>
         </p:nvSpPr>
@@ -3902,7 +3852,7 @@
       </p:sp>
       <p:cxnSp>
         <p:nvCxnSpPr>
-          <p:cNvPr id="12" name="Connector 11"/>
+          <p:cNvPr id="13" name="Connector 12"/>
           <p:cNvCxnSpPr/>
           <p:nvPr/>
         </p:nvCxnSpPr>
@@ -3938,7 +3888,7 @@
       </p:cxnSp>
       <p:sp>
         <p:nvSpPr>
-          <p:cNvPr id="13" name="TextBox 12"/>
+          <p:cNvPr id="14" name="TextBox 13"/>
           <p:cNvSpPr txBox="1"/>
           <p:nvPr/>
         </p:nvSpPr>
@@ -3981,7 +3931,7 @@
       </p:sp>
       <p:sp>
         <p:nvSpPr>
-          <p:cNvPr id="14" name="TextBox 13"/>
+          <p:cNvPr id="15" name="TextBox 14"/>
           <p:cNvSpPr txBox="1"/>
           <p:nvPr/>
         </p:nvSpPr>
@@ -4048,9 +3998,33 @@
         <p:nvPr/>
       </p:nvGrpSpPr>
       <p:grpSpPr/>
-      <p:sp>
-        <p:nvSpPr>
-          <p:cNvPr id="2" name="TextBox 1"/>
+      <p:pic>
+        <p:nvPicPr>
+          <p:cNvPr id="2" name="Picture 1" descr="Mivada_Icon_White_RGB_L.png"/>
+          <p:cNvPicPr>
+            <a:picLocks noChangeAspect="1"/>
+          </p:cNvPicPr>
+          <p:nvPr/>
+        </p:nvPicPr>
+        <p:blipFill>
+          <a:blip r:embed="rId2"/>
+          <a:stretch>
+            <a:fillRect/>
+          </a:stretch>
+        </p:blipFill>
+        <p:spPr>
+          <a:xfrm>
+            <a:off x="877824" y="457200"/>
+            <a:ext cx="402032" cy="237744"/>
+          </a:xfrm>
+          <a:prstGeom prst="rect">
+            <a:avLst/>
+          </a:prstGeom>
+        </p:spPr>
+      </p:pic>
+      <p:sp>
+        <p:nvSpPr>
+          <p:cNvPr id="3" name="TextBox 2"/>
           <p:cNvSpPr txBox="1"/>
           <p:nvPr/>
         </p:nvSpPr>
@@ -4093,7 +4067,7 @@
       </p:sp>
       <p:sp>
         <p:nvSpPr>
-          <p:cNvPr id="3" name="TextBox 2"/>
+          <p:cNvPr id="4" name="TextBox 3"/>
           <p:cNvSpPr txBox="1"/>
           <p:nvPr/>
         </p:nvSpPr>
@@ -4136,7 +4110,7 @@
       </p:sp>
       <p:sp>
         <p:nvSpPr>
-          <p:cNvPr id="4" name="TextBox 3"/>
+          <p:cNvPr id="5" name="TextBox 4"/>
           <p:cNvSpPr txBox="1"/>
           <p:nvPr/>
         </p:nvSpPr>
@@ -4188,7 +4162,7 @@
       </p:sp>
       <p:cxnSp>
         <p:nvCxnSpPr>
-          <p:cNvPr id="5" name="Connector 4"/>
+          <p:cNvPr id="6" name="Connector 5"/>
           <p:cNvCxnSpPr/>
           <p:nvPr/>
         </p:nvCxnSpPr>
@@ -4224,7 +4198,7 @@
       </p:cxnSp>
       <p:sp>
         <p:nvSpPr>
-          <p:cNvPr id="6" name="TextBox 5"/>
+          <p:cNvPr id="7" name="TextBox 6"/>
           <p:cNvSpPr txBox="1"/>
           <p:nvPr/>
         </p:nvSpPr>
@@ -4267,7 +4241,7 @@
       </p:sp>
       <p:sp>
         <p:nvSpPr>
-          <p:cNvPr id="7" name="TextBox 6"/>
+          <p:cNvPr id="8" name="TextBox 7"/>
           <p:cNvSpPr txBox="1"/>
           <p:nvPr/>
         </p:nvSpPr>
@@ -4332,7 +4306,7 @@
       </p:sp>
       <p:sp>
         <p:nvSpPr>
-          <p:cNvPr id="8" name="TextBox 7"/>
+          <p:cNvPr id="9" name="TextBox 8"/>
           <p:cNvSpPr txBox="1"/>
           <p:nvPr/>
         </p:nvSpPr>
@@ -4375,7 +4349,7 @@
       </p:sp>
       <p:cxnSp>
         <p:nvCxnSpPr>
-          <p:cNvPr id="9" name="Connector 8"/>
+          <p:cNvPr id="10" name="Connector 9"/>
           <p:cNvCxnSpPr/>
           <p:nvPr/>
         </p:nvCxnSpPr>
@@ -4411,7 +4385,7 @@
       </p:cxnSp>
       <p:sp>
         <p:nvSpPr>
-          <p:cNvPr id="10" name="TextBox 9"/>
+          <p:cNvPr id="11" name="TextBox 10"/>
           <p:cNvSpPr txBox="1"/>
           <p:nvPr/>
         </p:nvSpPr>
@@ -4454,7 +4428,7 @@
       </p:sp>
       <p:sp>
         <p:nvSpPr>
-          <p:cNvPr id="11" name="TextBox 10"/>
+          <p:cNvPr id="12" name="TextBox 11"/>
           <p:cNvSpPr txBox="1"/>
           <p:nvPr/>
         </p:nvSpPr>
@@ -4519,7 +4493,7 @@
       </p:sp>
       <p:sp>
         <p:nvSpPr>
-          <p:cNvPr id="12" name="TextBox 11"/>
+          <p:cNvPr id="13" name="TextBox 12"/>
           <p:cNvSpPr txBox="1"/>
           <p:nvPr/>
         </p:nvSpPr>
@@ -4562,7 +4536,7 @@
       </p:sp>
       <p:cxnSp>
         <p:nvCxnSpPr>
-          <p:cNvPr id="13" name="Connector 12"/>
+          <p:cNvPr id="14" name="Connector 13"/>
           <p:cNvCxnSpPr/>
           <p:nvPr/>
         </p:nvCxnSpPr>
@@ -4598,7 +4572,7 @@
       </p:cxnSp>
       <p:sp>
         <p:nvSpPr>
-          <p:cNvPr id="14" name="TextBox 13"/>
+          <p:cNvPr id="15" name="TextBox 14"/>
           <p:cNvSpPr txBox="1"/>
           <p:nvPr/>
         </p:nvSpPr>
@@ -4641,7 +4615,7 @@
       </p:sp>
       <p:sp>
         <p:nvSpPr>
-          <p:cNvPr id="15" name="TextBox 14"/>
+          <p:cNvPr id="16" name="TextBox 15"/>
           <p:cNvSpPr txBox="1"/>
           <p:nvPr/>
         </p:nvSpPr>
@@ -4706,7 +4680,7 @@
       </p:sp>
       <p:sp>
         <p:nvSpPr>
-          <p:cNvPr id="16" name="TextBox 15"/>
+          <p:cNvPr id="17" name="TextBox 16"/>
           <p:cNvSpPr txBox="1"/>
           <p:nvPr/>
         </p:nvSpPr>
@@ -4749,7 +4723,7 @@
       </p:sp>
       <p:cxnSp>
         <p:nvCxnSpPr>
-          <p:cNvPr id="17" name="Connector 16"/>
+          <p:cNvPr id="18" name="Connector 17"/>
           <p:cNvCxnSpPr/>
           <p:nvPr/>
         </p:nvCxnSpPr>
@@ -4785,7 +4759,7 @@
       </p:cxnSp>
       <p:sp>
         <p:nvSpPr>
-          <p:cNvPr id="18" name="TextBox 17"/>
+          <p:cNvPr id="19" name="TextBox 18"/>
           <p:cNvSpPr txBox="1"/>
           <p:nvPr/>
         </p:nvSpPr>
@@ -4828,7 +4802,7 @@
       </p:sp>
       <p:sp>
         <p:nvSpPr>
-          <p:cNvPr id="19" name="TextBox 18"/>
+          <p:cNvPr id="20" name="TextBox 19"/>
           <p:cNvSpPr txBox="1"/>
           <p:nvPr/>
         </p:nvSpPr>
@@ -4893,7 +4867,7 @@
       </p:sp>
       <p:sp>
         <p:nvSpPr>
-          <p:cNvPr id="20" name="TextBox 19"/>
+          <p:cNvPr id="21" name="TextBox 20"/>
           <p:cNvSpPr txBox="1"/>
           <p:nvPr/>
         </p:nvSpPr>
@@ -4936,7 +4910,7 @@
       </p:sp>
       <p:cxnSp>
         <p:nvCxnSpPr>
-          <p:cNvPr id="21" name="Connector 20"/>
+          <p:cNvPr id="22" name="Connector 21"/>
           <p:cNvCxnSpPr/>
           <p:nvPr/>
         </p:nvCxnSpPr>
@@ -4996,9 +4970,33 @@
         <p:nvPr/>
       </p:nvGrpSpPr>
       <p:grpSpPr/>
-      <p:sp>
-        <p:nvSpPr>
-          <p:cNvPr id="2" name="TextBox 1"/>
+      <p:pic>
+        <p:nvPicPr>
+          <p:cNvPr id="2" name="Picture 1" descr="Mivada_Icon_Melon_RGB_L.png"/>
+          <p:cNvPicPr>
+            <a:picLocks noChangeAspect="1"/>
+          </p:cNvPicPr>
+          <p:nvPr/>
+        </p:nvPicPr>
+        <p:blipFill>
+          <a:blip r:embed="rId2"/>
+          <a:stretch>
+            <a:fillRect/>
+          </a:stretch>
+        </p:blipFill>
+        <p:spPr>
+          <a:xfrm>
+            <a:off x="877824" y="457200"/>
+            <a:ext cx="402032" cy="237744"/>
+          </a:xfrm>
+          <a:prstGeom prst="rect">
+            <a:avLst/>
+          </a:prstGeom>
+        </p:spPr>
+      </p:pic>
+      <p:sp>
+        <p:nvSpPr>
+          <p:cNvPr id="3" name="TextBox 2"/>
           <p:cNvSpPr txBox="1"/>
           <p:nvPr/>
         </p:nvSpPr>
@@ -5041,7 +5039,7 @@
       </p:sp>
       <p:sp>
         <p:nvSpPr>
-          <p:cNvPr id="3" name="TextBox 2"/>
+          <p:cNvPr id="4" name="TextBox 3"/>
           <p:cNvSpPr txBox="1"/>
           <p:nvPr/>
         </p:nvSpPr>
@@ -5084,7 +5082,7 @@
       </p:sp>
       <p:sp>
         <p:nvSpPr>
-          <p:cNvPr id="4" name="TextBox 3"/>
+          <p:cNvPr id="5" name="TextBox 4"/>
           <p:cNvSpPr txBox="1"/>
           <p:nvPr/>
         </p:nvSpPr>
@@ -5136,7 +5134,7 @@
       </p:sp>
       <p:sp>
         <p:nvSpPr>
-          <p:cNvPr id="5" name="TextBox 4"/>
+          <p:cNvPr id="6" name="TextBox 5"/>
           <p:cNvSpPr txBox="1"/>
           <p:nvPr/>
         </p:nvSpPr>
@@ -5223,7 +5221,7 @@
       </p:sp>
       <p:cxnSp>
         <p:nvCxnSpPr>
-          <p:cNvPr id="6" name="Connector 5"/>
+          <p:cNvPr id="7" name="Connector 6"/>
           <p:cNvCxnSpPr/>
           <p:nvPr/>
         </p:nvCxnSpPr>
@@ -5259,7 +5257,7 @@
       </p:cxnSp>
       <p:sp>
         <p:nvSpPr>
-          <p:cNvPr id="7" name="TextBox 6"/>
+          <p:cNvPr id="8" name="TextBox 7"/>
           <p:cNvSpPr txBox="1"/>
           <p:nvPr/>
         </p:nvSpPr>
@@ -5346,7 +5344,7 @@
       </p:sp>
       <p:cxnSp>
         <p:nvCxnSpPr>
-          <p:cNvPr id="8" name="Connector 7"/>
+          <p:cNvPr id="9" name="Connector 8"/>
           <p:cNvCxnSpPr/>
           <p:nvPr/>
         </p:nvCxnSpPr>
@@ -5382,7 +5380,7 @@
       </p:cxnSp>
       <p:sp>
         <p:nvSpPr>
-          <p:cNvPr id="9" name="TextBox 8"/>
+          <p:cNvPr id="10" name="TextBox 9"/>
           <p:cNvSpPr txBox="1"/>
           <p:nvPr/>
         </p:nvSpPr>
@@ -5469,7 +5467,7 @@
       </p:sp>
       <p:cxnSp>
         <p:nvCxnSpPr>
-          <p:cNvPr id="10" name="Connector 9"/>
+          <p:cNvPr id="11" name="Connector 10"/>
           <p:cNvCxnSpPr/>
           <p:nvPr/>
         </p:nvCxnSpPr>
@@ -5505,7 +5503,7 @@
       </p:cxnSp>
       <p:sp>
         <p:nvSpPr>
-          <p:cNvPr id="11" name="TextBox 10"/>
+          <p:cNvPr id="12" name="TextBox 11"/>
           <p:cNvSpPr txBox="1"/>
           <p:nvPr/>
         </p:nvSpPr>
@@ -5616,9 +5614,33 @@
         <p:nvPr/>
       </p:nvGrpSpPr>
       <p:grpSpPr/>
-      <p:sp>
-        <p:nvSpPr>
-          <p:cNvPr id="2" name="TextBox 1"/>
+      <p:pic>
+        <p:nvPicPr>
+          <p:cNvPr id="2" name="Picture 1" descr="Mivada_Icon_White_RGB_L.png"/>
+          <p:cNvPicPr>
+            <a:picLocks noChangeAspect="1"/>
+          </p:cNvPicPr>
+          <p:nvPr/>
+        </p:nvPicPr>
+        <p:blipFill>
+          <a:blip r:embed="rId2"/>
+          <a:stretch>
+            <a:fillRect/>
+          </a:stretch>
+        </p:blipFill>
+        <p:spPr>
+          <a:xfrm>
+            <a:off x="877824" y="457200"/>
+            <a:ext cx="402032" cy="237744"/>
+          </a:xfrm>
+          <a:prstGeom prst="rect">
+            <a:avLst/>
+          </a:prstGeom>
+        </p:spPr>
+      </p:pic>
+      <p:sp>
+        <p:nvSpPr>
+          <p:cNvPr id="3" name="TextBox 2"/>
           <p:cNvSpPr txBox="1"/>
           <p:nvPr/>
         </p:nvSpPr>
@@ -5661,7 +5683,7 @@
       </p:sp>
       <p:sp>
         <p:nvSpPr>
-          <p:cNvPr id="3" name="TextBox 2"/>
+          <p:cNvPr id="4" name="TextBox 3"/>
           <p:cNvSpPr txBox="1"/>
           <p:nvPr/>
         </p:nvSpPr>
@@ -5704,7 +5726,7 @@
       </p:sp>
       <p:sp>
         <p:nvSpPr>
-          <p:cNvPr id="4" name="TextBox 3"/>
+          <p:cNvPr id="5" name="TextBox 4"/>
           <p:cNvSpPr txBox="1"/>
           <p:nvPr/>
         </p:nvSpPr>
@@ -5756,7 +5778,7 @@
       </p:sp>
       <p:sp>
         <p:nvSpPr>
-          <p:cNvPr id="5" name="TextBox 4"/>
+          <p:cNvPr id="6" name="TextBox 5"/>
           <p:cNvSpPr txBox="1"/>
           <p:nvPr/>
         </p:nvSpPr>
@@ -5799,7 +5821,7 @@
       </p:sp>
       <p:cxnSp>
         <p:nvCxnSpPr>
-          <p:cNvPr id="6" name="Connector 5"/>
+          <p:cNvPr id="7" name="Connector 6"/>
           <p:cNvCxnSpPr/>
           <p:nvPr/>
         </p:nvCxnSpPr>
@@ -5835,7 +5857,7 @@
       </p:cxnSp>
       <p:sp>
         <p:nvSpPr>
-          <p:cNvPr id="7" name="TextBox 6"/>
+          <p:cNvPr id="8" name="TextBox 7"/>
           <p:cNvSpPr txBox="1"/>
           <p:nvPr/>
         </p:nvSpPr>
@@ -5878,7 +5900,7 @@
       </p:sp>
       <p:sp>
         <p:nvSpPr>
-          <p:cNvPr id="8" name="TextBox 7"/>
+          <p:cNvPr id="9" name="TextBox 8"/>
           <p:cNvSpPr txBox="1"/>
           <p:nvPr/>
         </p:nvSpPr>
@@ -5939,7 +5961,7 @@
       </p:sp>
       <p:cxnSp>
         <p:nvCxnSpPr>
-          <p:cNvPr id="9" name="Connector 8"/>
+          <p:cNvPr id="10" name="Connector 9"/>
           <p:cNvCxnSpPr/>
           <p:nvPr/>
         </p:nvCxnSpPr>
@@ -5975,7 +5997,7 @@
       </p:cxnSp>
       <p:sp>
         <p:nvSpPr>
-          <p:cNvPr id="10" name="TextBox 9"/>
+          <p:cNvPr id="11" name="TextBox 10"/>
           <p:cNvSpPr txBox="1"/>
           <p:nvPr/>
         </p:nvSpPr>
@@ -6018,7 +6040,7 @@
       </p:sp>
       <p:sp>
         <p:nvSpPr>
-          <p:cNvPr id="11" name="TextBox 10"/>
+          <p:cNvPr id="12" name="TextBox 11"/>
           <p:cNvSpPr txBox="1"/>
           <p:nvPr/>
         </p:nvSpPr>
@@ -6097,7 +6119,7 @@
       </p:sp>
       <p:cxnSp>
         <p:nvCxnSpPr>
-          <p:cNvPr id="12" name="Connector 11"/>
+          <p:cNvPr id="13" name="Connector 12"/>
           <p:cNvCxnSpPr/>
           <p:nvPr/>
         </p:nvCxnSpPr>
@@ -6133,7 +6155,7 @@
       </p:cxnSp>
       <p:sp>
         <p:nvSpPr>
-          <p:cNvPr id="13" name="TextBox 12"/>
+          <p:cNvPr id="14" name="TextBox 13"/>
           <p:cNvSpPr txBox="1"/>
           <p:nvPr/>
         </p:nvSpPr>
@@ -6176,7 +6198,7 @@
       </p:sp>
       <p:sp>
         <p:nvSpPr>
-          <p:cNvPr id="14" name="TextBox 13"/>
+          <p:cNvPr id="15" name="TextBox 14"/>
           <p:cNvSpPr txBox="1"/>
           <p:nvPr/>
         </p:nvSpPr>
@@ -6237,7 +6259,7 @@
       </p:sp>
       <p:cxnSp>
         <p:nvCxnSpPr>
-          <p:cNvPr id="15" name="Connector 14"/>
+          <p:cNvPr id="16" name="Connector 15"/>
           <p:cNvCxnSpPr/>
           <p:nvPr/>
         </p:nvCxnSpPr>
@@ -6273,7 +6295,7 @@
       </p:cxnSp>
       <p:sp>
         <p:nvSpPr>
-          <p:cNvPr id="16" name="TextBox 15"/>
+          <p:cNvPr id="17" name="TextBox 16"/>
           <p:cNvSpPr txBox="1"/>
           <p:nvPr/>
         </p:nvSpPr>
@@ -6316,7 +6338,7 @@
       </p:sp>
       <p:sp>
         <p:nvSpPr>
-          <p:cNvPr id="17" name="TextBox 16"/>
+          <p:cNvPr id="18" name="TextBox 17"/>
           <p:cNvSpPr txBox="1"/>
           <p:nvPr/>
         </p:nvSpPr>
@@ -6395,7 +6417,7 @@
       </p:sp>
       <p:cxnSp>
         <p:nvCxnSpPr>
-          <p:cNvPr id="18" name="Connector 17"/>
+          <p:cNvPr id="19" name="Connector 18"/>
           <p:cNvCxnSpPr/>
           <p:nvPr/>
         </p:nvCxnSpPr>
@@ -6455,9 +6477,33 @@
         <p:nvPr/>
       </p:nvGrpSpPr>
       <p:grpSpPr/>
-      <p:sp>
-        <p:nvSpPr>
-          <p:cNvPr id="2" name="TextBox 1"/>
+      <p:pic>
+        <p:nvPicPr>
+          <p:cNvPr id="2" name="Picture 1" descr="Mivada_Icon_Melon_RGB_L.png"/>
+          <p:cNvPicPr>
+            <a:picLocks noChangeAspect="1"/>
+          </p:cNvPicPr>
+          <p:nvPr/>
+        </p:nvPicPr>
+        <p:blipFill>
+          <a:blip r:embed="rId2"/>
+          <a:stretch>
+            <a:fillRect/>
+          </a:stretch>
+        </p:blipFill>
+        <p:spPr>
+          <a:xfrm>
+            <a:off x="877824" y="457200"/>
+            <a:ext cx="402032" cy="237744"/>
+          </a:xfrm>
+          <a:prstGeom prst="rect">
+            <a:avLst/>
+          </a:prstGeom>
+        </p:spPr>
+      </p:pic>
+      <p:sp>
+        <p:nvSpPr>
+          <p:cNvPr id="3" name="TextBox 2"/>
           <p:cNvSpPr txBox="1"/>
           <p:nvPr/>
         </p:nvSpPr>
@@ -6500,7 +6546,7 @@
       </p:sp>
       <p:sp>
         <p:nvSpPr>
-          <p:cNvPr id="3" name="TextBox 2"/>
+          <p:cNvPr id="4" name="TextBox 3"/>
           <p:cNvSpPr txBox="1"/>
           <p:nvPr/>
         </p:nvSpPr>
@@ -6543,7 +6589,7 @@
       </p:sp>
       <p:sp>
         <p:nvSpPr>
-          <p:cNvPr id="4" name="Rectangle 3"/>
+          <p:cNvPr id="5" name="Rectangle 4"/>
           <p:cNvSpPr/>
           <p:nvPr/>
         </p:nvSpPr>
@@ -6587,7 +6633,7 @@
       </p:sp>
       <p:sp>
         <p:nvSpPr>
-          <p:cNvPr id="5" name="TextBox 4"/>
+          <p:cNvPr id="6" name="TextBox 5"/>
           <p:cNvSpPr txBox="1"/>
           <p:nvPr/>
         </p:nvSpPr>
@@ -6630,7 +6676,7 @@
       </p:sp>
       <p:sp>
         <p:nvSpPr>
-          <p:cNvPr id="6" name="TextBox 5"/>
+          <p:cNvPr id="7" name="TextBox 6"/>
           <p:cNvSpPr txBox="1"/>
           <p:nvPr/>
         </p:nvSpPr>
@@ -6673,7 +6719,7 @@
       </p:sp>
       <p:cxnSp>
         <p:nvCxnSpPr>
-          <p:cNvPr id="7" name="Connector 6"/>
+          <p:cNvPr id="8" name="Connector 7"/>
           <p:cNvCxnSpPr/>
           <p:nvPr/>
         </p:nvCxnSpPr>
@@ -6709,7 +6755,7 @@
       </p:cxnSp>
       <p:sp>
         <p:nvSpPr>
-          <p:cNvPr id="8" name="TextBox 7"/>
+          <p:cNvPr id="9" name="TextBox 8"/>
           <p:cNvSpPr txBox="1"/>
           <p:nvPr/>
         </p:nvSpPr>
@@ -6761,7 +6807,7 @@
       </p:sp>
       <p:sp>
         <p:nvSpPr>
-          <p:cNvPr id="9" name="TextBox 8"/>
+          <p:cNvPr id="10" name="TextBox 9"/>
           <p:cNvSpPr txBox="1"/>
           <p:nvPr/>
         </p:nvSpPr>
@@ -6804,7 +6850,7 @@
       </p:sp>
       <p:cxnSp>
         <p:nvCxnSpPr>
-          <p:cNvPr id="10" name="Connector 9"/>
+          <p:cNvPr id="11" name="Connector 10"/>
           <p:cNvCxnSpPr/>
           <p:nvPr/>
         </p:nvCxnSpPr>
@@ -6840,7 +6886,7 @@
       </p:cxnSp>
       <p:sp>
         <p:nvSpPr>
-          <p:cNvPr id="11" name="TextBox 10"/>
+          <p:cNvPr id="12" name="TextBox 11"/>
           <p:cNvSpPr txBox="1"/>
           <p:nvPr/>
         </p:nvSpPr>
@@ -6892,7 +6938,7 @@
       </p:sp>
       <p:sp>
         <p:nvSpPr>
-          <p:cNvPr id="12" name="TextBox 11"/>
+          <p:cNvPr id="13" name="TextBox 12"/>
           <p:cNvSpPr txBox="1"/>
           <p:nvPr/>
         </p:nvSpPr>
@@ -6935,7 +6981,7 @@
       </p:sp>
       <p:cxnSp>
         <p:nvCxnSpPr>
-          <p:cNvPr id="13" name="Connector 12"/>
+          <p:cNvPr id="14" name="Connector 13"/>
           <p:cNvCxnSpPr/>
           <p:nvPr/>
         </p:nvCxnSpPr>
@@ -6971,7 +7017,7 @@
       </p:cxnSp>
       <p:sp>
         <p:nvSpPr>
-          <p:cNvPr id="14" name="TextBox 13"/>
+          <p:cNvPr id="15" name="TextBox 14"/>
           <p:cNvSpPr txBox="1"/>
           <p:nvPr/>
         </p:nvSpPr>
@@ -7014,7 +7060,7 @@
       </p:sp>
       <p:sp>
         <p:nvSpPr>
-          <p:cNvPr id="15" name="TextBox 14"/>
+          <p:cNvPr id="16" name="TextBox 15"/>
           <p:cNvSpPr txBox="1"/>
           <p:nvPr/>
         </p:nvSpPr>
@@ -7081,9 +7127,33 @@
         <p:nvPr/>
       </p:nvGrpSpPr>
       <p:grpSpPr/>
-      <p:sp>
-        <p:nvSpPr>
-          <p:cNvPr id="2" name="TextBox 1"/>
+      <p:pic>
+        <p:nvPicPr>
+          <p:cNvPr id="2" name="Picture 1" descr="Mivada_Icon_White_RGB_L.png"/>
+          <p:cNvPicPr>
+            <a:picLocks noChangeAspect="1"/>
+          </p:cNvPicPr>
+          <p:nvPr/>
+        </p:nvPicPr>
+        <p:blipFill>
+          <a:blip r:embed="rId2"/>
+          <a:stretch>
+            <a:fillRect/>
+          </a:stretch>
+        </p:blipFill>
+        <p:spPr>
+          <a:xfrm>
+            <a:off x="877824" y="457200"/>
+            <a:ext cx="402032" cy="237744"/>
+          </a:xfrm>
+          <a:prstGeom prst="rect">
+            <a:avLst/>
+          </a:prstGeom>
+        </p:spPr>
+      </p:pic>
+      <p:sp>
+        <p:nvSpPr>
+          <p:cNvPr id="3" name="TextBox 2"/>
           <p:cNvSpPr txBox="1"/>
           <p:nvPr/>
         </p:nvSpPr>
@@ -7126,7 +7196,7 @@
       </p:sp>
       <p:sp>
         <p:nvSpPr>
-          <p:cNvPr id="3" name="TextBox 2"/>
+          <p:cNvPr id="4" name="TextBox 3"/>
           <p:cNvSpPr txBox="1"/>
           <p:nvPr/>
         </p:nvSpPr>
@@ -7169,7 +7239,7 @@
       </p:sp>
       <p:sp>
         <p:nvSpPr>
-          <p:cNvPr id="4" name="TextBox 3"/>
+          <p:cNvPr id="5" name="TextBox 4"/>
           <p:cNvSpPr txBox="1"/>
           <p:nvPr/>
         </p:nvSpPr>
@@ -7221,7 +7291,7 @@
       </p:sp>
       <p:sp>
         <p:nvSpPr>
-          <p:cNvPr id="5" name="TextBox 4"/>
+          <p:cNvPr id="6" name="TextBox 5"/>
           <p:cNvSpPr txBox="1"/>
           <p:nvPr/>
         </p:nvSpPr>
@@ -7308,7 +7378,7 @@
       </p:sp>
       <p:cxnSp>
         <p:nvCxnSpPr>
-          <p:cNvPr id="6" name="Connector 5"/>
+          <p:cNvPr id="7" name="Connector 6"/>
           <p:cNvCxnSpPr/>
           <p:nvPr/>
         </p:nvCxnSpPr>
@@ -7344,7 +7414,7 @@
       </p:cxnSp>
       <p:sp>
         <p:nvSpPr>
-          <p:cNvPr id="7" name="TextBox 6"/>
+          <p:cNvPr id="8" name="TextBox 7"/>
           <p:cNvSpPr txBox="1"/>
           <p:nvPr/>
         </p:nvSpPr>
@@ -7431,7 +7501,7 @@
       </p:sp>
       <p:cxnSp>
         <p:nvCxnSpPr>
-          <p:cNvPr id="8" name="Connector 7"/>
+          <p:cNvPr id="9" name="Connector 8"/>
           <p:cNvCxnSpPr/>
           <p:nvPr/>
         </p:nvCxnSpPr>
@@ -7467,7 +7537,7 @@
       </p:cxnSp>
       <p:sp>
         <p:nvSpPr>
-          <p:cNvPr id="9" name="TextBox 8"/>
+          <p:cNvPr id="10" name="TextBox 9"/>
           <p:cNvSpPr txBox="1"/>
           <p:nvPr/>
         </p:nvSpPr>
@@ -7578,61 +7648,30 @@
         <p:nvPr/>
       </p:nvGrpSpPr>
       <p:grpSpPr/>
-      <p:sp>
-        <p:nvSpPr>
-          <p:cNvPr id="2" name="Rounded Rectangle 1"/>
-          <p:cNvSpPr/>
-          <p:nvPr/>
-        </p:nvSpPr>
-        <p:spPr>
-          <a:xfrm>
-            <a:off x="877824" y="658368"/>
-            <a:ext cx="566928" cy="566928"/>
-          </a:xfrm>
-          <a:prstGeom prst="roundRect">
-            <a:avLst>
-              <a:gd name="adj" fmla="val 20000"/>
-            </a:avLst>
-          </a:prstGeom>
-          <a:solidFill>
-            <a:srgbClr val="EA493F"/>
-          </a:solidFill>
-          <a:ln>
-            <a:noFill/>
-          </a:ln>
-          <a:effectLst/>
-        </p:spPr>
-        <p:style>
-          <a:lnRef idx="1">
-            <a:schemeClr val="accent1"/>
-          </a:lnRef>
-          <a:fillRef idx="3">
-            <a:schemeClr val="accent1"/>
-          </a:fillRef>
-          <a:effectRef idx="2">
-            <a:schemeClr val="accent1"/>
-          </a:effectRef>
-          <a:fontRef idx="minor">
-            <a:schemeClr val="lt1"/>
-          </a:fontRef>
-        </p:style>
-        <p:txBody>
-          <a:bodyPr rtlCol="0" anchor="ctr" wrap="square" lIns="0" rIns="0" tIns="0" bIns="0"/>
-          <a:lstStyle/>
-          <a:p>
-            <a:pPr algn="ctr"/>
-            <a:r>
-              <a:rPr sz="2852" b="1" i="0" lang="en-AU" spc="-114">
-                <a:solidFill>
-                  <a:srgbClr val="FFFFFF"/>
-                </a:solidFill>
-                <a:latin typeface="Inter"/>
-              </a:rPr>
-              <a:t>M</a:t>
-            </a:r>
-          </a:p>
-        </p:txBody>
-      </p:sp>
+      <p:pic>
+        <p:nvPicPr>
+          <p:cNvPr id="2" name="Picture 1" descr="Mivada_Logo_2C_OnBlack_RGB_L.png"/>
+          <p:cNvPicPr>
+            <a:picLocks noChangeAspect="1"/>
+          </p:cNvPicPr>
+          <p:nvPr/>
+        </p:nvPicPr>
+        <p:blipFill>
+          <a:blip r:embed="rId2"/>
+          <a:stretch>
+            <a:fillRect/>
+          </a:stretch>
+        </p:blipFill>
+        <p:spPr>
+          <a:xfrm>
+            <a:off x="877824" y="749808"/>
+            <a:ext cx="2531685" cy="384048"/>
+          </a:xfrm>
+          <a:prstGeom prst="rect">
+            <a:avLst/>
+          </a:prstGeom>
+        </p:spPr>
+      </p:pic>
       <p:sp>
         <p:nvSpPr>
           <p:cNvPr id="3" name="TextBox 2"/>
@@ -7641,8 +7680,8 @@
         </p:nvSpPr>
         <p:spPr>
           <a:xfrm>
-            <a:off x="1591056" y="658368"/>
-            <a:ext cx="4572000" cy="566928"/>
+            <a:off x="877824" y="2194560"/>
+            <a:ext cx="7315200" cy="320040"/>
           </a:xfrm>
           <a:prstGeom prst="rect">
             <a:avLst/>
@@ -7650,7 +7689,7 @@
           <a:noFill/>
         </p:spPr>
         <p:txBody>
-          <a:bodyPr wrap="square" anchor="ctr" lIns="0" rIns="0" tIns="0" bIns="0"/>
+          <a:bodyPr wrap="square" anchor="t" lIns="0" rIns="0" tIns="0" bIns="0"/>
           <a:lstStyle/>
           <a:p>
             <a:pPr algn="l">
@@ -7665,13 +7704,13 @@
               </a:spcAft>
             </a:pPr>
             <a:r>
-              <a:rPr sz="2200" b="1" i="0" lang="en-AU" spc="-65">
-                <a:solidFill>
-                  <a:srgbClr val="FFFFFF"/>
-                </a:solidFill>
-                <a:latin typeface="Inter"/>
-              </a:rPr>
-              <a:t>Mivada</a:t>
+              <a:rPr sz="1200" b="1" i="0" lang="en-AU" spc="192" cap="all">
+                <a:solidFill>
+                  <a:srgbClr val="EA493F"/>
+                </a:solidFill>
+                <a:latin typeface="Inter"/>
+              </a:rPr>
+              <a:t>LET'S TALK</a:t>
             </a:r>
           </a:p>
         </p:txBody>
@@ -7684,49 +7723,6 @@
         </p:nvSpPr>
         <p:spPr>
           <a:xfrm>
-            <a:off x="877824" y="2194560"/>
-            <a:ext cx="7315200" cy="320040"/>
-          </a:xfrm>
-          <a:prstGeom prst="rect">
-            <a:avLst/>
-          </a:prstGeom>
-          <a:noFill/>
-        </p:spPr>
-        <p:txBody>
-          <a:bodyPr wrap="square" anchor="t" lIns="0" rIns="0" tIns="0" bIns="0"/>
-          <a:lstStyle/>
-          <a:p>
-            <a:pPr algn="l">
-              <a:lnSpc>
-                <a:spcPct val="100000"/>
-              </a:lnSpc>
-              <a:spcBef>
-                <a:spcPts val="0"/>
-              </a:spcBef>
-              <a:spcAft>
-                <a:spcPts val="0"/>
-              </a:spcAft>
-            </a:pPr>
-            <a:r>
-              <a:rPr sz="1200" b="1" i="0" lang="en-AU" spc="192" cap="all">
-                <a:solidFill>
-                  <a:srgbClr val="EA493F"/>
-                </a:solidFill>
-                <a:latin typeface="Inter"/>
-              </a:rPr>
-              <a:t>LET'S TALK</a:t>
-            </a:r>
-          </a:p>
-        </p:txBody>
-      </p:sp>
-      <p:sp>
-        <p:nvSpPr>
-          <p:cNvPr id="5" name="TextBox 4"/>
-          <p:cNvSpPr txBox="1"/>
-          <p:nvPr/>
-        </p:nvSpPr>
-        <p:spPr>
-          <a:xfrm>
             <a:off x="841248" y="2606040"/>
             <a:ext cx="10058400" cy="2743200"/>
           </a:xfrm>
@@ -7773,7 +7769,7 @@
       </p:sp>
       <p:cxnSp>
         <p:nvCxnSpPr>
-          <p:cNvPr id="6" name="Connector 5"/>
+          <p:cNvPr id="5" name="Connector 4"/>
           <p:cNvCxnSpPr/>
           <p:nvPr/>
         </p:nvCxnSpPr>
@@ -7809,7 +7805,7 @@
       </p:cxnSp>
       <p:sp>
         <p:nvSpPr>
-          <p:cNvPr id="7" name="TextBox 6"/>
+          <p:cNvPr id="6" name="TextBox 5"/>
           <p:cNvSpPr txBox="1"/>
           <p:nvPr/>
         </p:nvSpPr>
@@ -7852,7 +7848,7 @@
       </p:sp>
       <p:sp>
         <p:nvSpPr>
-          <p:cNvPr id="8" name="TextBox 7"/>
+          <p:cNvPr id="7" name="TextBox 6"/>
           <p:cNvSpPr txBox="1"/>
           <p:nvPr/>
         </p:nvSpPr>

</xml_diff>

<commit_message>
Editorial: single coral section label, fix Data & AI overlap, add clients + AMS pack
Core (build_pptx.py):
- Section label shown once only — the top-right slug, recoloured coral & enlarged
  (removed the duplicate body eyebrow from kpis/pillars/steps/split/pullquote/reasons;
  headlines nudged up).
- Data & AI (split): value column rebuilt full-width (key over value) — fixes the
  overlapping-text bug seen in PowerPoint.

Overview (mivada_overview.py):
- Drop duplicate eyebrow in head(); add a "Trusted by" clients slide after Who we are
  (clean name grid now; auto-swaps to assets/clients/clients-logos.png when added).

New: extra_slides_editorial.py -> Mivada_AMS_Services_editorial.pptx (7 slides) —
the supplied AMS/services slides rebuilt in Editorial (FIN & HCM coverage, two
engagement models, AMS framework, coverage timeline, governance tiers, team).
Regenerated editorial.pptx demo to match the core change.

https://claude.ai/code/session_018CuPeTbPKyC5roqRrfQGYh
</commit_message>
<xml_diff>
--- a/design-system/02-editorial/editorial.pptx
+++ b/design-system/02-editorial/editorial.pptx
@@ -3448,9 +3448,9 @@
               </a:spcAft>
             </a:pPr>
             <a:r>
-              <a:rPr sz="1050" b="1" i="0" lang="en-AU" spc="147" cap="all">
-                <a:solidFill>
-                  <a:srgbClr val="AEAEAE"/>
+              <a:rPr sz="1100" b="1" i="0" lang="en-AU" spc="154" cap="all">
+                <a:solidFill>
+                  <a:srgbClr val="EA493F"/>
                 </a:solidFill>
                 <a:latin typeface="Inter"/>
               </a:rPr>
@@ -3467,8 +3467,8 @@
         </p:nvSpPr>
         <p:spPr>
           <a:xfrm>
-            <a:off x="877824" y="841248"/>
-            <a:ext cx="7315200" cy="320040"/>
+            <a:off x="841248" y="932688"/>
+            <a:ext cx="7040880" cy="2468880"/>
           </a:xfrm>
           <a:prstGeom prst="rect">
             <a:avLst/>
@@ -3491,13 +3491,22 @@
               </a:spcAft>
             </a:pPr>
             <a:r>
-              <a:rPr sz="1200" b="1" i="0" lang="en-AU" spc="192" cap="all">
+              <a:rPr sz="4000" b="1" i="0" lang="en-AU" spc="-87">
+                <a:solidFill>
+                  <a:srgbClr val="111111"/>
+                </a:solidFill>
+                <a:latin typeface="Inter"/>
+              </a:rPr>
+              <a:t>We turn enterprise platforms into measurable </a:t>
+            </a:r>
+            <a:r>
+              <a:rPr sz="4000" b="1" i="0" lang="en-AU" spc="-87">
                 <a:solidFill>
                   <a:srgbClr val="EA493F"/>
                 </a:solidFill>
                 <a:latin typeface="Inter"/>
               </a:rPr>
-              <a:t>WHO WE ARE</a:t>
+              <a:t>human outcomes.</a:t>
             </a:r>
           </a:p>
         </p:txBody>
@@ -3510,58 +3519,6 @@
         </p:nvSpPr>
         <p:spPr>
           <a:xfrm>
-            <a:off x="841248" y="1280160"/>
-            <a:ext cx="7040880" cy="2468880"/>
-          </a:xfrm>
-          <a:prstGeom prst="rect">
-            <a:avLst/>
-          </a:prstGeom>
-          <a:noFill/>
-        </p:spPr>
-        <p:txBody>
-          <a:bodyPr wrap="square" anchor="t" lIns="0" rIns="0" tIns="0" bIns="0"/>
-          <a:lstStyle/>
-          <a:p>
-            <a:pPr algn="l">
-              <a:lnSpc>
-                <a:spcPct val="100000"/>
-              </a:lnSpc>
-              <a:spcBef>
-                <a:spcPts val="0"/>
-              </a:spcBef>
-              <a:spcAft>
-                <a:spcPts val="0"/>
-              </a:spcAft>
-            </a:pPr>
-            <a:r>
-              <a:rPr sz="4000" b="1" i="0" lang="en-AU" spc="-87">
-                <a:solidFill>
-                  <a:srgbClr val="111111"/>
-                </a:solidFill>
-                <a:latin typeface="Inter"/>
-              </a:rPr>
-              <a:t>We turn enterprise platforms into measurable </a:t>
-            </a:r>
-            <a:r>
-              <a:rPr sz="4000" b="1" i="0" lang="en-AU" spc="-87">
-                <a:solidFill>
-                  <a:srgbClr val="EA493F"/>
-                </a:solidFill>
-                <a:latin typeface="Inter"/>
-              </a:rPr>
-              <a:t>human outcomes.</a:t>
-            </a:r>
-          </a:p>
-        </p:txBody>
-      </p:sp>
-      <p:sp>
-        <p:nvSpPr>
-          <p:cNvPr id="6" name="TextBox 5"/>
-          <p:cNvSpPr txBox="1"/>
-          <p:nvPr/>
-        </p:nvSpPr>
-        <p:spPr>
-          <a:xfrm>
             <a:off x="8183879" y="1874519"/>
             <a:ext cx="3127248" cy="2194560"/>
           </a:xfrm>
@@ -3599,7 +3556,7 @@
       </p:sp>
       <p:cxnSp>
         <p:nvCxnSpPr>
-          <p:cNvPr id="7" name="Connector 6"/>
+          <p:cNvPr id="6" name="Connector 5"/>
           <p:cNvCxnSpPr/>
           <p:nvPr/>
         </p:nvCxnSpPr>
@@ -3635,55 +3592,55 @@
       </p:cxnSp>
       <p:sp>
         <p:nvSpPr>
+          <p:cNvPr id="7" name="TextBox 6"/>
+          <p:cNvSpPr txBox="1"/>
+          <p:nvPr/>
+        </p:nvSpPr>
+        <p:spPr>
+          <a:xfrm>
+            <a:off x="877824" y="4160520"/>
+            <a:ext cx="3314090" cy="1051560"/>
+          </a:xfrm>
+          <a:prstGeom prst="rect">
+            <a:avLst/>
+          </a:prstGeom>
+          <a:noFill/>
+        </p:spPr>
+        <p:txBody>
+          <a:bodyPr wrap="square" anchor="b" lIns="0" rIns="0" tIns="0" bIns="0"/>
+          <a:lstStyle/>
+          <a:p>
+            <a:pPr algn="l">
+              <a:lnSpc>
+                <a:spcPct val="92000"/>
+              </a:lnSpc>
+              <a:spcBef>
+                <a:spcPts val="0"/>
+              </a:spcBef>
+              <a:spcAft>
+                <a:spcPts val="0"/>
+              </a:spcAft>
+            </a:pPr>
+            <a:r>
+              <a:rPr sz="5800" b="1" i="0" lang="en-AU" spc="-203">
+                <a:solidFill>
+                  <a:srgbClr val="111111"/>
+                </a:solidFill>
+                <a:latin typeface="Inter"/>
+              </a:rPr>
+              <a:t>2014</a:t>
+            </a:r>
+          </a:p>
+        </p:txBody>
+      </p:sp>
+      <p:sp>
+        <p:nvSpPr>
           <p:cNvPr id="8" name="TextBox 7"/>
           <p:cNvSpPr txBox="1"/>
           <p:nvPr/>
         </p:nvSpPr>
         <p:spPr>
           <a:xfrm>
-            <a:off x="877824" y="4160520"/>
-            <a:ext cx="3314090" cy="1051560"/>
-          </a:xfrm>
-          <a:prstGeom prst="rect">
-            <a:avLst/>
-          </a:prstGeom>
-          <a:noFill/>
-        </p:spPr>
-        <p:txBody>
-          <a:bodyPr wrap="square" anchor="b" lIns="0" rIns="0" tIns="0" bIns="0"/>
-          <a:lstStyle/>
-          <a:p>
-            <a:pPr algn="l">
-              <a:lnSpc>
-                <a:spcPct val="92000"/>
-              </a:lnSpc>
-              <a:spcBef>
-                <a:spcPts val="0"/>
-              </a:spcBef>
-              <a:spcAft>
-                <a:spcPts val="0"/>
-              </a:spcAft>
-            </a:pPr>
-            <a:r>
-              <a:rPr sz="5800" b="1" i="0" lang="en-AU" spc="-203">
-                <a:solidFill>
-                  <a:srgbClr val="111111"/>
-                </a:solidFill>
-                <a:latin typeface="Inter"/>
-              </a:rPr>
-              <a:t>2014</a:t>
-            </a:r>
-          </a:p>
-        </p:txBody>
-      </p:sp>
-      <p:sp>
-        <p:nvSpPr>
-          <p:cNvPr id="9" name="TextBox 8"/>
-          <p:cNvSpPr txBox="1"/>
-          <p:nvPr/>
-        </p:nvSpPr>
-        <p:spPr>
-          <a:xfrm>
             <a:off x="877824" y="5294376"/>
             <a:ext cx="3250082" cy="640080"/>
           </a:xfrm>
@@ -3721,7 +3678,7 @@
       </p:sp>
       <p:cxnSp>
         <p:nvCxnSpPr>
-          <p:cNvPr id="10" name="Connector 9"/>
+          <p:cNvPr id="9" name="Connector 8"/>
           <p:cNvCxnSpPr/>
           <p:nvPr/>
         </p:nvCxnSpPr>
@@ -3757,64 +3714,64 @@
       </p:cxnSp>
       <p:sp>
         <p:nvSpPr>
+          <p:cNvPr id="10" name="TextBox 9"/>
+          <p:cNvSpPr txBox="1"/>
+          <p:nvPr/>
+        </p:nvSpPr>
+        <p:spPr>
+          <a:xfrm>
+            <a:off x="4667402" y="4160520"/>
+            <a:ext cx="3003194" cy="1051560"/>
+          </a:xfrm>
+          <a:prstGeom prst="rect">
+            <a:avLst/>
+          </a:prstGeom>
+          <a:noFill/>
+        </p:spPr>
+        <p:txBody>
+          <a:bodyPr wrap="square" anchor="b" lIns="0" rIns="0" tIns="0" bIns="0"/>
+          <a:lstStyle/>
+          <a:p>
+            <a:pPr algn="l">
+              <a:lnSpc>
+                <a:spcPct val="92000"/>
+              </a:lnSpc>
+              <a:spcBef>
+                <a:spcPts val="0"/>
+              </a:spcBef>
+              <a:spcAft>
+                <a:spcPts val="0"/>
+              </a:spcAft>
+            </a:pPr>
+            <a:r>
+              <a:rPr sz="5800" b="1" i="0" lang="en-AU" spc="-203">
+                <a:solidFill>
+                  <a:srgbClr val="111111"/>
+                </a:solidFill>
+                <a:latin typeface="Inter"/>
+              </a:rPr>
+              <a:t>120</a:t>
+            </a:r>
+            <a:r>
+              <a:rPr sz="5800" b="1" i="0" lang="en-AU" spc="-203">
+                <a:solidFill>
+                  <a:srgbClr val="EA493F"/>
+                </a:solidFill>
+                <a:latin typeface="Inter"/>
+              </a:rPr>
+              <a:t>+</a:t>
+            </a:r>
+          </a:p>
+        </p:txBody>
+      </p:sp>
+      <p:sp>
+        <p:nvSpPr>
           <p:cNvPr id="11" name="TextBox 10"/>
           <p:cNvSpPr txBox="1"/>
           <p:nvPr/>
         </p:nvSpPr>
         <p:spPr>
           <a:xfrm>
-            <a:off x="4667402" y="4160520"/>
-            <a:ext cx="3003194" cy="1051560"/>
-          </a:xfrm>
-          <a:prstGeom prst="rect">
-            <a:avLst/>
-          </a:prstGeom>
-          <a:noFill/>
-        </p:spPr>
-        <p:txBody>
-          <a:bodyPr wrap="square" anchor="b" lIns="0" rIns="0" tIns="0" bIns="0"/>
-          <a:lstStyle/>
-          <a:p>
-            <a:pPr algn="l">
-              <a:lnSpc>
-                <a:spcPct val="92000"/>
-              </a:lnSpc>
-              <a:spcBef>
-                <a:spcPts val="0"/>
-              </a:spcBef>
-              <a:spcAft>
-                <a:spcPts val="0"/>
-              </a:spcAft>
-            </a:pPr>
-            <a:r>
-              <a:rPr sz="5800" b="1" i="0" lang="en-AU" spc="-203">
-                <a:solidFill>
-                  <a:srgbClr val="111111"/>
-                </a:solidFill>
-                <a:latin typeface="Inter"/>
-              </a:rPr>
-              <a:t>120</a:t>
-            </a:r>
-            <a:r>
-              <a:rPr sz="5800" b="1" i="0" lang="en-AU" spc="-203">
-                <a:solidFill>
-                  <a:srgbClr val="EA493F"/>
-                </a:solidFill>
-                <a:latin typeface="Inter"/>
-              </a:rPr>
-              <a:t>+</a:t>
-            </a:r>
-          </a:p>
-        </p:txBody>
-      </p:sp>
-      <p:sp>
-        <p:nvSpPr>
-          <p:cNvPr id="12" name="TextBox 11"/>
-          <p:cNvSpPr txBox="1"/>
-          <p:nvPr/>
-        </p:nvSpPr>
-        <p:spPr>
-          <a:xfrm>
             <a:off x="4667402" y="5294376"/>
             <a:ext cx="2939186" cy="640080"/>
           </a:xfrm>
@@ -3852,7 +3809,7 @@
       </p:sp>
       <p:cxnSp>
         <p:nvCxnSpPr>
-          <p:cNvPr id="13" name="Connector 12"/>
+          <p:cNvPr id="12" name="Connector 11"/>
           <p:cNvCxnSpPr/>
           <p:nvPr/>
         </p:nvCxnSpPr>
@@ -3888,7 +3845,7 @@
       </p:cxnSp>
       <p:sp>
         <p:nvSpPr>
-          <p:cNvPr id="14" name="TextBox 13"/>
+          <p:cNvPr id="13" name="TextBox 12"/>
           <p:cNvSpPr txBox="1"/>
           <p:nvPr/>
         </p:nvSpPr>
@@ -3931,7 +3888,7 @@
       </p:sp>
       <p:sp>
         <p:nvSpPr>
-          <p:cNvPr id="15" name="TextBox 14"/>
+          <p:cNvPr id="14" name="TextBox 13"/>
           <p:cNvSpPr txBox="1"/>
           <p:nvPr/>
         </p:nvSpPr>
@@ -4054,9 +4011,9 @@
               </a:spcAft>
             </a:pPr>
             <a:r>
-              <a:rPr sz="1050" b="1" i="0" lang="en-AU" spc="147" cap="all">
-                <a:solidFill>
-                  <a:srgbClr val="777777"/>
+              <a:rPr sz="1100" b="1" i="0" lang="en-AU" spc="154" cap="all">
+                <a:solidFill>
+                  <a:srgbClr val="EA493F"/>
                 </a:solidFill>
                 <a:latin typeface="Inter"/>
               </a:rPr>
@@ -4073,50 +4030,7 @@
         </p:nvSpPr>
         <p:spPr>
           <a:xfrm>
-            <a:off x="877824" y="786384"/>
-            <a:ext cx="7315200" cy="320040"/>
-          </a:xfrm>
-          <a:prstGeom prst="rect">
-            <a:avLst/>
-          </a:prstGeom>
-          <a:noFill/>
-        </p:spPr>
-        <p:txBody>
-          <a:bodyPr wrap="square" anchor="t" lIns="0" rIns="0" tIns="0" bIns="0"/>
-          <a:lstStyle/>
-          <a:p>
-            <a:pPr algn="l">
-              <a:lnSpc>
-                <a:spcPct val="100000"/>
-              </a:lnSpc>
-              <a:spcBef>
-                <a:spcPts val="0"/>
-              </a:spcBef>
-              <a:spcAft>
-                <a:spcPts val="0"/>
-              </a:spcAft>
-            </a:pPr>
-            <a:r>
-              <a:rPr sz="1200" b="1" i="0" lang="en-AU" spc="192" cap="all">
-                <a:solidFill>
-                  <a:srgbClr val="EA493F"/>
-                </a:solidFill>
-                <a:latin typeface="Inter"/>
-              </a:rPr>
-              <a:t>FOUR SERVICE PILLARS</a:t>
-            </a:r>
-          </a:p>
-        </p:txBody>
-      </p:sp>
-      <p:sp>
-        <p:nvSpPr>
-          <p:cNvPr id="5" name="TextBox 4"/>
-          <p:cNvSpPr txBox="1"/>
-          <p:nvPr/>
-        </p:nvSpPr>
-        <p:spPr>
-          <a:xfrm>
-            <a:off x="841248" y="1170432"/>
+            <a:off x="841248" y="868680"/>
             <a:ext cx="10058400" cy="1005840"/>
           </a:xfrm>
           <a:prstGeom prst="rect">
@@ -4162,7 +4076,7 @@
       </p:sp>
       <p:cxnSp>
         <p:nvCxnSpPr>
-          <p:cNvPr id="6" name="Connector 5"/>
+          <p:cNvPr id="5" name="Connector 4"/>
           <p:cNvCxnSpPr/>
           <p:nvPr/>
         </p:nvCxnSpPr>
@@ -4198,14 +4112,57 @@
       </p:cxnSp>
       <p:sp>
         <p:nvSpPr>
+          <p:cNvPr id="6" name="TextBox 5"/>
+          <p:cNvSpPr txBox="1"/>
+          <p:nvPr/>
+        </p:nvSpPr>
+        <p:spPr>
+          <a:xfrm>
+            <a:off x="877824" y="2523744"/>
+            <a:ext cx="1005840" cy="822960"/>
+          </a:xfrm>
+          <a:prstGeom prst="rect">
+            <a:avLst/>
+          </a:prstGeom>
+          <a:noFill/>
+        </p:spPr>
+        <p:txBody>
+          <a:bodyPr wrap="square" anchor="t" lIns="0" rIns="0" tIns="0" bIns="0"/>
+          <a:lstStyle/>
+          <a:p>
+            <a:pPr algn="l">
+              <a:lnSpc>
+                <a:spcPct val="100000"/>
+              </a:lnSpc>
+              <a:spcBef>
+                <a:spcPts val="0"/>
+              </a:spcBef>
+              <a:spcAft>
+                <a:spcPts val="0"/>
+              </a:spcAft>
+            </a:pPr>
+            <a:r>
+              <a:rPr sz="3200" b="1" i="0" lang="en-AU" spc="-96">
+                <a:solidFill>
+                  <a:srgbClr val="EA493F"/>
+                </a:solidFill>
+                <a:latin typeface="Inter"/>
+              </a:rPr>
+              <a:t>01</a:t>
+            </a:r>
+          </a:p>
+        </p:txBody>
+      </p:sp>
+      <p:sp>
+        <p:nvSpPr>
           <p:cNvPr id="7" name="TextBox 6"/>
           <p:cNvSpPr txBox="1"/>
           <p:nvPr/>
         </p:nvSpPr>
         <p:spPr>
           <a:xfrm>
-            <a:off x="877824" y="2523744"/>
-            <a:ext cx="1005840" cy="822960"/>
+            <a:off x="2020824" y="2487168"/>
+            <a:ext cx="7040880" cy="777240"/>
           </a:xfrm>
           <a:prstGeom prst="rect">
             <a:avLst/>
@@ -4228,13 +4185,35 @@
               </a:spcAft>
             </a:pPr>
             <a:r>
-              <a:rPr sz="3200" b="1" i="0" lang="en-AU" spc="-96">
-                <a:solidFill>
-                  <a:srgbClr val="EA493F"/>
-                </a:solidFill>
-                <a:latin typeface="Inter"/>
-              </a:rPr>
-              <a:t>01</a:t>
+              <a:rPr sz="2100" b="1" i="0" lang="en-AU" spc="-42">
+                <a:solidFill>
+                  <a:srgbClr val="FFFFFF"/>
+                </a:solidFill>
+                <a:latin typeface="Inter"/>
+              </a:rPr>
+              <a:t>Workday &amp; ERP</a:t>
+            </a:r>
+          </a:p>
+          <a:p>
+            <a:pPr algn="l">
+              <a:lnSpc>
+                <a:spcPct val="112000"/>
+              </a:lnSpc>
+              <a:spcBef>
+                <a:spcPts val="400"/>
+              </a:spcBef>
+              <a:spcAft>
+                <a:spcPts val="0"/>
+              </a:spcAft>
+            </a:pPr>
+            <a:r>
+              <a:rPr sz="1200" b="0" i="0" lang="en-AU" spc="0">
+                <a:solidFill>
+                  <a:srgbClr val="CFCFCF"/>
+                </a:solidFill>
+                <a:latin typeface="Inter"/>
+              </a:rPr>
+              <a:t>Implementation, optimisation and managed support for Workday HCM, Financials and adjacent ERP.</a:t>
             </a:r>
           </a:p>
         </p:txBody>
@@ -4247,71 +4226,6 @@
         </p:nvSpPr>
         <p:spPr>
           <a:xfrm>
-            <a:off x="2020824" y="2487168"/>
-            <a:ext cx="7040880" cy="777240"/>
-          </a:xfrm>
-          <a:prstGeom prst="rect">
-            <a:avLst/>
-          </a:prstGeom>
-          <a:noFill/>
-        </p:spPr>
-        <p:txBody>
-          <a:bodyPr wrap="square" anchor="t" lIns="0" rIns="0" tIns="0" bIns="0"/>
-          <a:lstStyle/>
-          <a:p>
-            <a:pPr algn="l">
-              <a:lnSpc>
-                <a:spcPct val="100000"/>
-              </a:lnSpc>
-              <a:spcBef>
-                <a:spcPts val="0"/>
-              </a:spcBef>
-              <a:spcAft>
-                <a:spcPts val="0"/>
-              </a:spcAft>
-            </a:pPr>
-            <a:r>
-              <a:rPr sz="2100" b="1" i="0" lang="en-AU" spc="-42">
-                <a:solidFill>
-                  <a:srgbClr val="FFFFFF"/>
-                </a:solidFill>
-                <a:latin typeface="Inter"/>
-              </a:rPr>
-              <a:t>Workday &amp; ERP</a:t>
-            </a:r>
-          </a:p>
-          <a:p>
-            <a:pPr algn="l">
-              <a:lnSpc>
-                <a:spcPct val="112000"/>
-              </a:lnSpc>
-              <a:spcBef>
-                <a:spcPts val="400"/>
-              </a:spcBef>
-              <a:spcAft>
-                <a:spcPts val="0"/>
-              </a:spcAft>
-            </a:pPr>
-            <a:r>
-              <a:rPr sz="1200" b="0" i="0" lang="en-AU" spc="0">
-                <a:solidFill>
-                  <a:srgbClr val="CFCFCF"/>
-                </a:solidFill>
-                <a:latin typeface="Inter"/>
-              </a:rPr>
-              <a:t>Implementation, optimisation and managed support for Workday HCM, Financials and adjacent ERP.</a:t>
-            </a:r>
-          </a:p>
-        </p:txBody>
-      </p:sp>
-      <p:sp>
-        <p:nvSpPr>
-          <p:cNvPr id="9" name="TextBox 8"/>
-          <p:cNvSpPr txBox="1"/>
-          <p:nvPr/>
-        </p:nvSpPr>
-        <p:spPr>
-          <a:xfrm>
             <a:off x="9722815" y="2578608"/>
             <a:ext cx="1591056" cy="457200"/>
           </a:xfrm>
@@ -4349,7 +4263,7 @@
       </p:sp>
       <p:cxnSp>
         <p:nvCxnSpPr>
-          <p:cNvPr id="10" name="Connector 9"/>
+          <p:cNvPr id="9" name="Connector 8"/>
           <p:cNvCxnSpPr/>
           <p:nvPr/>
         </p:nvCxnSpPr>
@@ -4385,14 +4299,57 @@
       </p:cxnSp>
       <p:sp>
         <p:nvSpPr>
+          <p:cNvPr id="10" name="TextBox 9"/>
+          <p:cNvSpPr txBox="1"/>
+          <p:nvPr/>
+        </p:nvSpPr>
+        <p:spPr>
+          <a:xfrm>
+            <a:off x="877824" y="3410712"/>
+            <a:ext cx="1005840" cy="822960"/>
+          </a:xfrm>
+          <a:prstGeom prst="rect">
+            <a:avLst/>
+          </a:prstGeom>
+          <a:noFill/>
+        </p:spPr>
+        <p:txBody>
+          <a:bodyPr wrap="square" anchor="t" lIns="0" rIns="0" tIns="0" bIns="0"/>
+          <a:lstStyle/>
+          <a:p>
+            <a:pPr algn="l">
+              <a:lnSpc>
+                <a:spcPct val="100000"/>
+              </a:lnSpc>
+              <a:spcBef>
+                <a:spcPts val="0"/>
+              </a:spcBef>
+              <a:spcAft>
+                <a:spcPts val="0"/>
+              </a:spcAft>
+            </a:pPr>
+            <a:r>
+              <a:rPr sz="3200" b="1" i="0" lang="en-AU" spc="-96">
+                <a:solidFill>
+                  <a:srgbClr val="EA493F"/>
+                </a:solidFill>
+                <a:latin typeface="Inter"/>
+              </a:rPr>
+              <a:t>02</a:t>
+            </a:r>
+          </a:p>
+        </p:txBody>
+      </p:sp>
+      <p:sp>
+        <p:nvSpPr>
           <p:cNvPr id="11" name="TextBox 10"/>
           <p:cNvSpPr txBox="1"/>
           <p:nvPr/>
         </p:nvSpPr>
         <p:spPr>
           <a:xfrm>
-            <a:off x="877824" y="3410712"/>
-            <a:ext cx="1005840" cy="822960"/>
+            <a:off x="2020824" y="3374136"/>
+            <a:ext cx="7040880" cy="777240"/>
           </a:xfrm>
           <a:prstGeom prst="rect">
             <a:avLst/>
@@ -4415,13 +4372,35 @@
               </a:spcAft>
             </a:pPr>
             <a:r>
-              <a:rPr sz="3200" b="1" i="0" lang="en-AU" spc="-96">
-                <a:solidFill>
-                  <a:srgbClr val="EA493F"/>
-                </a:solidFill>
-                <a:latin typeface="Inter"/>
-              </a:rPr>
-              <a:t>02</a:t>
+              <a:rPr sz="2100" b="1" i="0" lang="en-AU" spc="-42">
+                <a:solidFill>
+                  <a:srgbClr val="FFFFFF"/>
+                </a:solidFill>
+                <a:latin typeface="Inter"/>
+              </a:rPr>
+              <a:t>Payroll consulting</a:t>
+            </a:r>
+          </a:p>
+          <a:p>
+            <a:pPr algn="l">
+              <a:lnSpc>
+                <a:spcPct val="112000"/>
+              </a:lnSpc>
+              <a:spcBef>
+                <a:spcPts val="400"/>
+              </a:spcBef>
+              <a:spcAft>
+                <a:spcPts val="0"/>
+              </a:spcAft>
+            </a:pPr>
+            <a:r>
+              <a:rPr sz="1200" b="0" i="0" lang="en-AU" spc="0">
+                <a:solidFill>
+                  <a:srgbClr val="CFCFCF"/>
+                </a:solidFill>
+                <a:latin typeface="Inter"/>
+              </a:rPr>
+              <a:t>Compliant, accurate payroll across complex awards and multi-entity structures.</a:t>
             </a:r>
           </a:p>
         </p:txBody>
@@ -4434,71 +4413,6 @@
         </p:nvSpPr>
         <p:spPr>
           <a:xfrm>
-            <a:off x="2020824" y="3374136"/>
-            <a:ext cx="7040880" cy="777240"/>
-          </a:xfrm>
-          <a:prstGeom prst="rect">
-            <a:avLst/>
-          </a:prstGeom>
-          <a:noFill/>
-        </p:spPr>
-        <p:txBody>
-          <a:bodyPr wrap="square" anchor="t" lIns="0" rIns="0" tIns="0" bIns="0"/>
-          <a:lstStyle/>
-          <a:p>
-            <a:pPr algn="l">
-              <a:lnSpc>
-                <a:spcPct val="100000"/>
-              </a:lnSpc>
-              <a:spcBef>
-                <a:spcPts val="0"/>
-              </a:spcBef>
-              <a:spcAft>
-                <a:spcPts val="0"/>
-              </a:spcAft>
-            </a:pPr>
-            <a:r>
-              <a:rPr sz="2100" b="1" i="0" lang="en-AU" spc="-42">
-                <a:solidFill>
-                  <a:srgbClr val="FFFFFF"/>
-                </a:solidFill>
-                <a:latin typeface="Inter"/>
-              </a:rPr>
-              <a:t>Payroll consulting</a:t>
-            </a:r>
-          </a:p>
-          <a:p>
-            <a:pPr algn="l">
-              <a:lnSpc>
-                <a:spcPct val="112000"/>
-              </a:lnSpc>
-              <a:spcBef>
-                <a:spcPts val="400"/>
-              </a:spcBef>
-              <a:spcAft>
-                <a:spcPts val="0"/>
-              </a:spcAft>
-            </a:pPr>
-            <a:r>
-              <a:rPr sz="1200" b="0" i="0" lang="en-AU" spc="0">
-                <a:solidFill>
-                  <a:srgbClr val="CFCFCF"/>
-                </a:solidFill>
-                <a:latin typeface="Inter"/>
-              </a:rPr>
-              <a:t>Compliant, accurate payroll across complex awards and multi-entity structures.</a:t>
-            </a:r>
-          </a:p>
-        </p:txBody>
-      </p:sp>
-      <p:sp>
-        <p:nvSpPr>
-          <p:cNvPr id="13" name="TextBox 12"/>
-          <p:cNvSpPr txBox="1"/>
-          <p:nvPr/>
-        </p:nvSpPr>
-        <p:spPr>
-          <a:xfrm>
             <a:off x="9722815" y="3465576"/>
             <a:ext cx="1591056" cy="457200"/>
           </a:xfrm>
@@ -4536,7 +4450,7 @@
       </p:sp>
       <p:cxnSp>
         <p:nvCxnSpPr>
-          <p:cNvPr id="14" name="Connector 13"/>
+          <p:cNvPr id="13" name="Connector 12"/>
           <p:cNvCxnSpPr/>
           <p:nvPr/>
         </p:nvCxnSpPr>
@@ -4572,14 +4486,57 @@
       </p:cxnSp>
       <p:sp>
         <p:nvSpPr>
+          <p:cNvPr id="14" name="TextBox 13"/>
+          <p:cNvSpPr txBox="1"/>
+          <p:nvPr/>
+        </p:nvSpPr>
+        <p:spPr>
+          <a:xfrm>
+            <a:off x="877824" y="4297680"/>
+            <a:ext cx="1005840" cy="822960"/>
+          </a:xfrm>
+          <a:prstGeom prst="rect">
+            <a:avLst/>
+          </a:prstGeom>
+          <a:noFill/>
+        </p:spPr>
+        <p:txBody>
+          <a:bodyPr wrap="square" anchor="t" lIns="0" rIns="0" tIns="0" bIns="0"/>
+          <a:lstStyle/>
+          <a:p>
+            <a:pPr algn="l">
+              <a:lnSpc>
+                <a:spcPct val="100000"/>
+              </a:lnSpc>
+              <a:spcBef>
+                <a:spcPts val="0"/>
+              </a:spcBef>
+              <a:spcAft>
+                <a:spcPts val="0"/>
+              </a:spcAft>
+            </a:pPr>
+            <a:r>
+              <a:rPr sz="3200" b="1" i="0" lang="en-AU" spc="-96">
+                <a:solidFill>
+                  <a:srgbClr val="EA493F"/>
+                </a:solidFill>
+                <a:latin typeface="Inter"/>
+              </a:rPr>
+              <a:t>03</a:t>
+            </a:r>
+          </a:p>
+        </p:txBody>
+      </p:sp>
+      <p:sp>
+        <p:nvSpPr>
           <p:cNvPr id="15" name="TextBox 14"/>
           <p:cNvSpPr txBox="1"/>
           <p:nvPr/>
         </p:nvSpPr>
         <p:spPr>
           <a:xfrm>
-            <a:off x="877824" y="4297680"/>
-            <a:ext cx="1005840" cy="822960"/>
+            <a:off x="2020824" y="4261104"/>
+            <a:ext cx="7040880" cy="777240"/>
           </a:xfrm>
           <a:prstGeom prst="rect">
             <a:avLst/>
@@ -4602,13 +4559,35 @@
               </a:spcAft>
             </a:pPr>
             <a:r>
-              <a:rPr sz="3200" b="1" i="0" lang="en-AU" spc="-96">
-                <a:solidFill>
-                  <a:srgbClr val="EA493F"/>
-                </a:solidFill>
-                <a:latin typeface="Inter"/>
-              </a:rPr>
-              <a:t>03</a:t>
+              <a:rPr sz="2100" b="1" i="0" lang="en-AU" spc="-42">
+                <a:solidFill>
+                  <a:srgbClr val="FFFFFF"/>
+                </a:solidFill>
+                <a:latin typeface="Inter"/>
+              </a:rPr>
+              <a:t>Data &amp; AI</a:t>
+            </a:r>
+          </a:p>
+          <a:p>
+            <a:pPr algn="l">
+              <a:lnSpc>
+                <a:spcPct val="112000"/>
+              </a:lnSpc>
+              <a:spcBef>
+                <a:spcPts val="400"/>
+              </a:spcBef>
+              <a:spcAft>
+                <a:spcPts val="0"/>
+              </a:spcAft>
+            </a:pPr>
+            <a:r>
+              <a:rPr sz="1200" b="0" i="0" lang="en-AU" spc="0">
+                <a:solidFill>
+                  <a:srgbClr val="CFCFCF"/>
+                </a:solidFill>
+                <a:latin typeface="Inter"/>
+              </a:rPr>
+              <a:t>Lakehouse architecture, governed analytics and applied AI on your people and finance data.</a:t>
             </a:r>
           </a:p>
         </p:txBody>
@@ -4621,71 +4600,6 @@
         </p:nvSpPr>
         <p:spPr>
           <a:xfrm>
-            <a:off x="2020824" y="4261104"/>
-            <a:ext cx="7040880" cy="777240"/>
-          </a:xfrm>
-          <a:prstGeom prst="rect">
-            <a:avLst/>
-          </a:prstGeom>
-          <a:noFill/>
-        </p:spPr>
-        <p:txBody>
-          <a:bodyPr wrap="square" anchor="t" lIns="0" rIns="0" tIns="0" bIns="0"/>
-          <a:lstStyle/>
-          <a:p>
-            <a:pPr algn="l">
-              <a:lnSpc>
-                <a:spcPct val="100000"/>
-              </a:lnSpc>
-              <a:spcBef>
-                <a:spcPts val="0"/>
-              </a:spcBef>
-              <a:spcAft>
-                <a:spcPts val="0"/>
-              </a:spcAft>
-            </a:pPr>
-            <a:r>
-              <a:rPr sz="2100" b="1" i="0" lang="en-AU" spc="-42">
-                <a:solidFill>
-                  <a:srgbClr val="FFFFFF"/>
-                </a:solidFill>
-                <a:latin typeface="Inter"/>
-              </a:rPr>
-              <a:t>Data &amp; AI</a:t>
-            </a:r>
-          </a:p>
-          <a:p>
-            <a:pPr algn="l">
-              <a:lnSpc>
-                <a:spcPct val="112000"/>
-              </a:lnSpc>
-              <a:spcBef>
-                <a:spcPts val="400"/>
-              </a:spcBef>
-              <a:spcAft>
-                <a:spcPts val="0"/>
-              </a:spcAft>
-            </a:pPr>
-            <a:r>
-              <a:rPr sz="1200" b="0" i="0" lang="en-AU" spc="0">
-                <a:solidFill>
-                  <a:srgbClr val="CFCFCF"/>
-                </a:solidFill>
-                <a:latin typeface="Inter"/>
-              </a:rPr>
-              <a:t>Lakehouse architecture, governed analytics and applied AI on your people and finance data.</a:t>
-            </a:r>
-          </a:p>
-        </p:txBody>
-      </p:sp>
-      <p:sp>
-        <p:nvSpPr>
-          <p:cNvPr id="17" name="TextBox 16"/>
-          <p:cNvSpPr txBox="1"/>
-          <p:nvPr/>
-        </p:nvSpPr>
-        <p:spPr>
-          <a:xfrm>
             <a:off x="9722815" y="4352544"/>
             <a:ext cx="1591056" cy="457200"/>
           </a:xfrm>
@@ -4723,7 +4637,7 @@
       </p:sp>
       <p:cxnSp>
         <p:nvCxnSpPr>
-          <p:cNvPr id="18" name="Connector 17"/>
+          <p:cNvPr id="17" name="Connector 16"/>
           <p:cNvCxnSpPr/>
           <p:nvPr/>
         </p:nvCxnSpPr>
@@ -4759,14 +4673,57 @@
       </p:cxnSp>
       <p:sp>
         <p:nvSpPr>
+          <p:cNvPr id="18" name="TextBox 17"/>
+          <p:cNvSpPr txBox="1"/>
+          <p:nvPr/>
+        </p:nvSpPr>
+        <p:spPr>
+          <a:xfrm>
+            <a:off x="877824" y="5184648"/>
+            <a:ext cx="1005840" cy="822960"/>
+          </a:xfrm>
+          <a:prstGeom prst="rect">
+            <a:avLst/>
+          </a:prstGeom>
+          <a:noFill/>
+        </p:spPr>
+        <p:txBody>
+          <a:bodyPr wrap="square" anchor="t" lIns="0" rIns="0" tIns="0" bIns="0"/>
+          <a:lstStyle/>
+          <a:p>
+            <a:pPr algn="l">
+              <a:lnSpc>
+                <a:spcPct val="100000"/>
+              </a:lnSpc>
+              <a:spcBef>
+                <a:spcPts val="0"/>
+              </a:spcBef>
+              <a:spcAft>
+                <a:spcPts val="0"/>
+              </a:spcAft>
+            </a:pPr>
+            <a:r>
+              <a:rPr sz="3200" b="1" i="0" lang="en-AU" spc="-96">
+                <a:solidFill>
+                  <a:srgbClr val="EA493F"/>
+                </a:solidFill>
+                <a:latin typeface="Inter"/>
+              </a:rPr>
+              <a:t>04</a:t>
+            </a:r>
+          </a:p>
+        </p:txBody>
+      </p:sp>
+      <p:sp>
+        <p:nvSpPr>
           <p:cNvPr id="19" name="TextBox 18"/>
           <p:cNvSpPr txBox="1"/>
           <p:nvPr/>
         </p:nvSpPr>
         <p:spPr>
           <a:xfrm>
-            <a:off x="877824" y="5184648"/>
-            <a:ext cx="1005840" cy="822960"/>
+            <a:off x="2020824" y="5148072"/>
+            <a:ext cx="7040880" cy="777240"/>
           </a:xfrm>
           <a:prstGeom prst="rect">
             <a:avLst/>
@@ -4789,13 +4746,35 @@
               </a:spcAft>
             </a:pPr>
             <a:r>
-              <a:rPr sz="3200" b="1" i="0" lang="en-AU" spc="-96">
-                <a:solidFill>
-                  <a:srgbClr val="EA493F"/>
-                </a:solidFill>
-                <a:latin typeface="Inter"/>
-              </a:rPr>
-              <a:t>04</a:t>
+              <a:rPr sz="2100" b="1" i="0" lang="en-AU" spc="-42">
+                <a:solidFill>
+                  <a:srgbClr val="FFFFFF"/>
+                </a:solidFill>
+                <a:latin typeface="Inter"/>
+              </a:rPr>
+              <a:t>Intelligent automation</a:t>
+            </a:r>
+          </a:p>
+          <a:p>
+            <a:pPr algn="l">
+              <a:lnSpc>
+                <a:spcPct val="112000"/>
+              </a:lnSpc>
+              <a:spcBef>
+                <a:spcPts val="400"/>
+              </a:spcBef>
+              <a:spcAft>
+                <a:spcPts val="0"/>
+              </a:spcAft>
+            </a:pPr>
+            <a:r>
+              <a:rPr sz="1200" b="0" i="0" lang="en-AU" spc="0">
+                <a:solidFill>
+                  <a:srgbClr val="CFCFCF"/>
+                </a:solidFill>
+                <a:latin typeface="Inter"/>
+              </a:rPr>
+              <a:t>RPA, ML and process design combined to remove low-value work.</a:t>
             </a:r>
           </a:p>
         </p:txBody>
@@ -4808,71 +4787,6 @@
         </p:nvSpPr>
         <p:spPr>
           <a:xfrm>
-            <a:off x="2020824" y="5148072"/>
-            <a:ext cx="7040880" cy="777240"/>
-          </a:xfrm>
-          <a:prstGeom prst="rect">
-            <a:avLst/>
-          </a:prstGeom>
-          <a:noFill/>
-        </p:spPr>
-        <p:txBody>
-          <a:bodyPr wrap="square" anchor="t" lIns="0" rIns="0" tIns="0" bIns="0"/>
-          <a:lstStyle/>
-          <a:p>
-            <a:pPr algn="l">
-              <a:lnSpc>
-                <a:spcPct val="100000"/>
-              </a:lnSpc>
-              <a:spcBef>
-                <a:spcPts val="0"/>
-              </a:spcBef>
-              <a:spcAft>
-                <a:spcPts val="0"/>
-              </a:spcAft>
-            </a:pPr>
-            <a:r>
-              <a:rPr sz="2100" b="1" i="0" lang="en-AU" spc="-42">
-                <a:solidFill>
-                  <a:srgbClr val="FFFFFF"/>
-                </a:solidFill>
-                <a:latin typeface="Inter"/>
-              </a:rPr>
-              <a:t>Intelligent automation</a:t>
-            </a:r>
-          </a:p>
-          <a:p>
-            <a:pPr algn="l">
-              <a:lnSpc>
-                <a:spcPct val="112000"/>
-              </a:lnSpc>
-              <a:spcBef>
-                <a:spcPts val="400"/>
-              </a:spcBef>
-              <a:spcAft>
-                <a:spcPts val="0"/>
-              </a:spcAft>
-            </a:pPr>
-            <a:r>
-              <a:rPr sz="1200" b="0" i="0" lang="en-AU" spc="0">
-                <a:solidFill>
-                  <a:srgbClr val="CFCFCF"/>
-                </a:solidFill>
-                <a:latin typeface="Inter"/>
-              </a:rPr>
-              <a:t>RPA, ML and process design combined to remove low-value work.</a:t>
-            </a:r>
-          </a:p>
-        </p:txBody>
-      </p:sp>
-      <p:sp>
-        <p:nvSpPr>
-          <p:cNvPr id="21" name="TextBox 20"/>
-          <p:cNvSpPr txBox="1"/>
-          <p:nvPr/>
-        </p:nvSpPr>
-        <p:spPr>
-          <a:xfrm>
             <a:off x="9722815" y="5239512"/>
             <a:ext cx="1591056" cy="457200"/>
           </a:xfrm>
@@ -4910,7 +4824,7 @@
       </p:sp>
       <p:cxnSp>
         <p:nvCxnSpPr>
-          <p:cNvPr id="22" name="Connector 21"/>
+          <p:cNvPr id="21" name="Connector 20"/>
           <p:cNvCxnSpPr/>
           <p:nvPr/>
         </p:nvCxnSpPr>
@@ -5026,9 +4940,9 @@
               </a:spcAft>
             </a:pPr>
             <a:r>
-              <a:rPr sz="1050" b="1" i="0" lang="en-AU" spc="147" cap="all">
-                <a:solidFill>
-                  <a:srgbClr val="AEAEAE"/>
+              <a:rPr sz="1100" b="1" i="0" lang="en-AU" spc="154" cap="all">
+                <a:solidFill>
+                  <a:srgbClr val="EA493F"/>
                 </a:solidFill>
                 <a:latin typeface="Inter"/>
               </a:rPr>
@@ -5045,8 +4959,8 @@
         </p:nvSpPr>
         <p:spPr>
           <a:xfrm>
-            <a:off x="877824" y="841248"/>
-            <a:ext cx="7315200" cy="320040"/>
+            <a:off x="841248" y="914400"/>
+            <a:ext cx="10424160" cy="1005840"/>
           </a:xfrm>
           <a:prstGeom prst="rect">
             <a:avLst/>
@@ -5069,13 +4983,22 @@
               </a:spcAft>
             </a:pPr>
             <a:r>
-              <a:rPr sz="1200" b="1" i="0" lang="en-AU" spc="192" cap="all">
+              <a:rPr sz="3400" b="1" i="0" lang="en-AU" spc="-74">
+                <a:solidFill>
+                  <a:srgbClr val="111111"/>
+                </a:solidFill>
+                <a:latin typeface="Inter"/>
+              </a:rPr>
+              <a:t>Understand the people </a:t>
+            </a:r>
+            <a:r>
+              <a:rPr sz="3400" b="1" i="0" lang="en-AU" spc="-74">
                 <a:solidFill>
                   <a:srgbClr val="EA493F"/>
                 </a:solidFill>
                 <a:latin typeface="Inter"/>
               </a:rPr>
-              <a:t>THINK HUMAN FIRST</a:t>
+              <a:t>before the technology.</a:t>
             </a:r>
           </a:p>
         </p:txBody>
@@ -5088,58 +5011,6 @@
         </p:nvSpPr>
         <p:spPr>
           <a:xfrm>
-            <a:off x="841248" y="1225296"/>
-            <a:ext cx="10424160" cy="1005840"/>
-          </a:xfrm>
-          <a:prstGeom prst="rect">
-            <a:avLst/>
-          </a:prstGeom>
-          <a:noFill/>
-        </p:spPr>
-        <p:txBody>
-          <a:bodyPr wrap="square" anchor="t" lIns="0" rIns="0" tIns="0" bIns="0"/>
-          <a:lstStyle/>
-          <a:p>
-            <a:pPr algn="l">
-              <a:lnSpc>
-                <a:spcPct val="100000"/>
-              </a:lnSpc>
-              <a:spcBef>
-                <a:spcPts val="0"/>
-              </a:spcBef>
-              <a:spcAft>
-                <a:spcPts val="0"/>
-              </a:spcAft>
-            </a:pPr>
-            <a:r>
-              <a:rPr sz="3400" b="1" i="0" lang="en-AU" spc="-74">
-                <a:solidFill>
-                  <a:srgbClr val="111111"/>
-                </a:solidFill>
-                <a:latin typeface="Inter"/>
-              </a:rPr>
-              <a:t>Understand the people </a:t>
-            </a:r>
-            <a:r>
-              <a:rPr sz="3400" b="1" i="0" lang="en-AU" spc="-74">
-                <a:solidFill>
-                  <a:srgbClr val="EA493F"/>
-                </a:solidFill>
-                <a:latin typeface="Inter"/>
-              </a:rPr>
-              <a:t>before the technology.</a:t>
-            </a:r>
-          </a:p>
-        </p:txBody>
-      </p:sp>
-      <p:sp>
-        <p:nvSpPr>
-          <p:cNvPr id="6" name="TextBox 5"/>
-          <p:cNvSpPr txBox="1"/>
-          <p:nvPr/>
-        </p:nvSpPr>
-        <p:spPr>
-          <a:xfrm>
             <a:off x="877824" y="2971800"/>
             <a:ext cx="2380411" cy="2286000"/>
           </a:xfrm>
@@ -5221,7 +5092,7 @@
       </p:sp>
       <p:cxnSp>
         <p:nvCxnSpPr>
-          <p:cNvPr id="7" name="Connector 6"/>
+          <p:cNvPr id="6" name="Connector 5"/>
           <p:cNvCxnSpPr/>
           <p:nvPr/>
         </p:nvCxnSpPr>
@@ -5257,7 +5128,7 @@
       </p:cxnSp>
       <p:sp>
         <p:nvSpPr>
-          <p:cNvPr id="8" name="TextBox 7"/>
+          <p:cNvPr id="7" name="TextBox 6"/>
           <p:cNvSpPr txBox="1"/>
           <p:nvPr/>
         </p:nvSpPr>
@@ -5344,7 +5215,7 @@
       </p:sp>
       <p:cxnSp>
         <p:nvCxnSpPr>
-          <p:cNvPr id="9" name="Connector 8"/>
+          <p:cNvPr id="8" name="Connector 7"/>
           <p:cNvCxnSpPr/>
           <p:nvPr/>
         </p:nvCxnSpPr>
@@ -5380,7 +5251,7 @@
       </p:cxnSp>
       <p:sp>
         <p:nvSpPr>
-          <p:cNvPr id="10" name="TextBox 9"/>
+          <p:cNvPr id="9" name="TextBox 8"/>
           <p:cNvSpPr txBox="1"/>
           <p:nvPr/>
         </p:nvSpPr>
@@ -5467,7 +5338,7 @@
       </p:sp>
       <p:cxnSp>
         <p:nvCxnSpPr>
-          <p:cNvPr id="11" name="Connector 10"/>
+          <p:cNvPr id="10" name="Connector 9"/>
           <p:cNvCxnSpPr/>
           <p:nvPr/>
         </p:nvCxnSpPr>
@@ -5503,7 +5374,7 @@
       </p:cxnSp>
       <p:sp>
         <p:nvSpPr>
-          <p:cNvPr id="12" name="TextBox 11"/>
+          <p:cNvPr id="11" name="TextBox 10"/>
           <p:cNvSpPr txBox="1"/>
           <p:nvPr/>
         </p:nvSpPr>
@@ -5670,9 +5541,9 @@
               </a:spcAft>
             </a:pPr>
             <a:r>
-              <a:rPr sz="1050" b="1" i="0" lang="en-AU" spc="147" cap="all">
-                <a:solidFill>
-                  <a:srgbClr val="777777"/>
+              <a:rPr sz="1100" b="1" i="0" lang="en-AU" spc="154" cap="all">
+                <a:solidFill>
+                  <a:srgbClr val="EA493F"/>
                 </a:solidFill>
                 <a:latin typeface="Inter"/>
               </a:rPr>
@@ -5689,8 +5560,8 @@
         </p:nvSpPr>
         <p:spPr>
           <a:xfrm>
-            <a:off x="877824" y="1051560"/>
-            <a:ext cx="5029200" cy="320040"/>
+            <a:off x="841248" y="1097280"/>
+            <a:ext cx="4937760" cy="1737360"/>
           </a:xfrm>
           <a:prstGeom prst="rect">
             <a:avLst/>
@@ -5713,13 +5584,22 @@
               </a:spcAft>
             </a:pPr>
             <a:r>
-              <a:rPr sz="1200" b="1" i="0" lang="en-AU" spc="192" cap="all">
+              <a:rPr sz="3600" b="1" i="0" lang="en-AU" spc="-79">
+                <a:solidFill>
+                  <a:srgbClr val="FFFFFF"/>
+                </a:solidFill>
+                <a:latin typeface="Inter"/>
+              </a:rPr>
+              <a:t>Decisions made on </a:t>
+            </a:r>
+            <a:r>
+              <a:rPr sz="3600" b="1" i="0" lang="en-AU" spc="-79">
                 <a:solidFill>
                   <a:srgbClr val="EA493F"/>
                 </a:solidFill>
                 <a:latin typeface="Inter"/>
               </a:rPr>
-              <a:t>CAPABILITY SPOTLIGHT</a:t>
+              <a:t>current data.</a:t>
             </a:r>
           </a:p>
         </p:txBody>
@@ -5732,58 +5612,6 @@
         </p:nvSpPr>
         <p:spPr>
           <a:xfrm>
-            <a:off x="841248" y="1463040"/>
-            <a:ext cx="4937760" cy="1737360"/>
-          </a:xfrm>
-          <a:prstGeom prst="rect">
-            <a:avLst/>
-          </a:prstGeom>
-          <a:noFill/>
-        </p:spPr>
-        <p:txBody>
-          <a:bodyPr wrap="square" anchor="t" lIns="0" rIns="0" tIns="0" bIns="0"/>
-          <a:lstStyle/>
-          <a:p>
-            <a:pPr algn="l">
-              <a:lnSpc>
-                <a:spcPct val="100000"/>
-              </a:lnSpc>
-              <a:spcBef>
-                <a:spcPts val="0"/>
-              </a:spcBef>
-              <a:spcAft>
-                <a:spcPts val="0"/>
-              </a:spcAft>
-            </a:pPr>
-            <a:r>
-              <a:rPr sz="3600" b="1" i="0" lang="en-AU" spc="-79">
-                <a:solidFill>
-                  <a:srgbClr val="FFFFFF"/>
-                </a:solidFill>
-                <a:latin typeface="Inter"/>
-              </a:rPr>
-              <a:t>Decisions made on </a:t>
-            </a:r>
-            <a:r>
-              <a:rPr sz="3600" b="1" i="0" lang="en-AU" spc="-79">
-                <a:solidFill>
-                  <a:srgbClr val="EA493F"/>
-                </a:solidFill>
-                <a:latin typeface="Inter"/>
-              </a:rPr>
-              <a:t>current data.</a:t>
-            </a:r>
-          </a:p>
-        </p:txBody>
-      </p:sp>
-      <p:sp>
-        <p:nvSpPr>
-          <p:cNvPr id="6" name="TextBox 5"/>
-          <p:cNvSpPr txBox="1"/>
-          <p:nvPr/>
-        </p:nvSpPr>
-        <p:spPr>
-          <a:xfrm>
             <a:off x="877824" y="3611880"/>
             <a:ext cx="4572000" cy="2011680"/>
           </a:xfrm>
@@ -5821,7 +5649,7 @@
       </p:sp>
       <p:cxnSp>
         <p:nvCxnSpPr>
-          <p:cNvPr id="7" name="Connector 6"/>
+          <p:cNvPr id="6" name="Connector 5"/>
           <p:cNvCxnSpPr/>
           <p:nvPr/>
         </p:nvCxnSpPr>
@@ -5857,14 +5685,57 @@
       </p:cxnSp>
       <p:sp>
         <p:nvSpPr>
+          <p:cNvPr id="7" name="TextBox 6"/>
+          <p:cNvSpPr txBox="1"/>
+          <p:nvPr/>
+        </p:nvSpPr>
+        <p:spPr>
+          <a:xfrm>
+            <a:off x="6355080" y="1417320"/>
+            <a:ext cx="4958791" cy="292608"/>
+          </a:xfrm>
+          <a:prstGeom prst="rect">
+            <a:avLst/>
+          </a:prstGeom>
+          <a:noFill/>
+        </p:spPr>
+        <p:txBody>
+          <a:bodyPr wrap="square" anchor="t" lIns="0" rIns="0" tIns="0" bIns="0"/>
+          <a:lstStyle/>
+          <a:p>
+            <a:pPr algn="l">
+              <a:lnSpc>
+                <a:spcPct val="100000"/>
+              </a:lnSpc>
+              <a:spcBef>
+                <a:spcPts val="0"/>
+              </a:spcBef>
+              <a:spcAft>
+                <a:spcPts val="0"/>
+              </a:spcAft>
+            </a:pPr>
+            <a:r>
+              <a:rPr sz="1050" b="1" i="0" lang="en-AU" spc="147" cap="all">
+                <a:solidFill>
+                  <a:srgbClr val="EA493F"/>
+                </a:solidFill>
+                <a:latin typeface="Inter"/>
+              </a:rPr>
+              <a:t>ARCHITECTURE</a:t>
+            </a:r>
+          </a:p>
+        </p:txBody>
+      </p:sp>
+      <p:sp>
+        <p:nvSpPr>
           <p:cNvPr id="8" name="TextBox 7"/>
           <p:cNvSpPr txBox="1"/>
           <p:nvPr/>
         </p:nvSpPr>
         <p:spPr>
           <a:xfrm>
-            <a:off x="6355080" y="1380744"/>
-            <a:ext cx="1417320" cy="731520"/>
+            <a:off x="6355080" y="1728216"/>
+            <a:ext cx="4958791" cy="457200"/>
           </a:xfrm>
           <a:prstGeom prst="rect">
             <a:avLst/>
@@ -5877,60 +5748,17 @@
           <a:p>
             <a:pPr algn="l">
               <a:lnSpc>
-                <a:spcPct val="105000"/>
-              </a:lnSpc>
-              <a:spcBef>
-                <a:spcPts val="0"/>
-              </a:spcBef>
-              <a:spcAft>
-                <a:spcPts val="0"/>
-              </a:spcAft>
-            </a:pPr>
-            <a:r>
-              <a:rPr sz="1050" b="1" i="0" lang="en-AU" spc="126" cap="all">
-                <a:solidFill>
-                  <a:srgbClr val="EA493F"/>
-                </a:solidFill>
-                <a:latin typeface="Inter"/>
-              </a:rPr>
-              <a:t>ARCHITECTURE</a:t>
-            </a:r>
-          </a:p>
-        </p:txBody>
-      </p:sp>
-      <p:sp>
-        <p:nvSpPr>
-          <p:cNvPr id="9" name="TextBox 8"/>
-          <p:cNvSpPr txBox="1"/>
-          <p:nvPr/>
-        </p:nvSpPr>
-        <p:spPr>
-          <a:xfrm>
-            <a:off x="7863840" y="1344168"/>
-            <a:ext cx="3450031" cy="822960"/>
-          </a:xfrm>
-          <a:prstGeom prst="rect">
-            <a:avLst/>
-          </a:prstGeom>
-          <a:noFill/>
-        </p:spPr>
-        <p:txBody>
-          <a:bodyPr wrap="square" anchor="ctr" lIns="0" rIns="0" tIns="0" bIns="0"/>
-          <a:lstStyle/>
-          <a:p>
-            <a:pPr algn="l">
-              <a:lnSpc>
-                <a:spcPct val="118000"/>
-              </a:lnSpc>
-              <a:spcBef>
-                <a:spcPts val="0"/>
-              </a:spcBef>
-              <a:spcAft>
-                <a:spcPts val="0"/>
-              </a:spcAft>
-            </a:pPr>
-            <a:r>
-              <a:rPr sz="1300" b="0" i="0" lang="en-AU" spc="0">
+                <a:spcPct val="110000"/>
+              </a:lnSpc>
+              <a:spcBef>
+                <a:spcPts val="0"/>
+              </a:spcBef>
+              <a:spcAft>
+                <a:spcPts val="0"/>
+              </a:spcAft>
+            </a:pPr>
+            <a:r>
+              <a:rPr sz="1400" b="0" i="0" lang="en-AU" spc="-7">
                 <a:solidFill>
                   <a:srgbClr val="D6D6D6"/>
                 </a:solidFill>
@@ -5939,7 +5767,7 @@
               <a:t>Designed </a:t>
             </a:r>
             <a:r>
-              <a:rPr sz="1300" b="1" i="0" lang="en-AU" spc="0">
+              <a:rPr sz="1400" b="1" i="0" lang="en-AU" spc="-7">
                 <a:solidFill>
                   <a:srgbClr val="FFFFFF"/>
                 </a:solidFill>
@@ -5948,7 +5776,7 @@
               <a:t>Lakehouse architectures</a:t>
             </a:r>
             <a:r>
-              <a:rPr sz="1300" b="0" i="0" lang="en-AU" spc="0">
+              <a:rPr sz="1400" b="0" i="0" lang="en-AU" spc="-7">
                 <a:solidFill>
                   <a:srgbClr val="D6D6D6"/>
                 </a:solidFill>
@@ -5961,13 +5789,13 @@
       </p:sp>
       <p:cxnSp>
         <p:nvCxnSpPr>
-          <p:cNvPr id="10" name="Connector 9"/>
+          <p:cNvPr id="9" name="Connector 8"/>
           <p:cNvCxnSpPr/>
           <p:nvPr/>
         </p:nvCxnSpPr>
         <p:spPr>
           <a:xfrm>
-            <a:off x="6355080" y="2203704"/>
+            <a:off x="6355080" y="2331720"/>
             <a:ext cx="4958791" cy="0"/>
           </a:xfrm>
           <a:prstGeom prst="bentConnector3">
@@ -5997,14 +5825,57 @@
       </p:cxnSp>
       <p:sp>
         <p:nvSpPr>
+          <p:cNvPr id="10" name="TextBox 9"/>
+          <p:cNvSpPr txBox="1"/>
+          <p:nvPr/>
+        </p:nvSpPr>
+        <p:spPr>
+          <a:xfrm>
+            <a:off x="6355080" y="2514600"/>
+            <a:ext cx="4958791" cy="292608"/>
+          </a:xfrm>
+          <a:prstGeom prst="rect">
+            <a:avLst/>
+          </a:prstGeom>
+          <a:noFill/>
+        </p:spPr>
+        <p:txBody>
+          <a:bodyPr wrap="square" anchor="t" lIns="0" rIns="0" tIns="0" bIns="0"/>
+          <a:lstStyle/>
+          <a:p>
+            <a:pPr algn="l">
+              <a:lnSpc>
+                <a:spcPct val="100000"/>
+              </a:lnSpc>
+              <a:spcBef>
+                <a:spcPts val="0"/>
+              </a:spcBef>
+              <a:spcAft>
+                <a:spcPts val="0"/>
+              </a:spcAft>
+            </a:pPr>
+            <a:r>
+              <a:rPr sz="1050" b="1" i="0" lang="en-AU" spc="147" cap="all">
+                <a:solidFill>
+                  <a:srgbClr val="EA493F"/>
+                </a:solidFill>
+                <a:latin typeface="Inter"/>
+              </a:rPr>
+              <a:t>PIPELINES</a:t>
+            </a:r>
+          </a:p>
+        </p:txBody>
+      </p:sp>
+      <p:sp>
+        <p:nvSpPr>
           <p:cNvPr id="11" name="TextBox 10"/>
           <p:cNvSpPr txBox="1"/>
           <p:nvPr/>
         </p:nvSpPr>
         <p:spPr>
           <a:xfrm>
-            <a:off x="6355080" y="2350008"/>
-            <a:ext cx="1417320" cy="731520"/>
+            <a:off x="6355080" y="2825496"/>
+            <a:ext cx="4958791" cy="457200"/>
           </a:xfrm>
           <a:prstGeom prst="rect">
             <a:avLst/>
@@ -6017,60 +5888,17 @@
           <a:p>
             <a:pPr algn="l">
               <a:lnSpc>
-                <a:spcPct val="105000"/>
-              </a:lnSpc>
-              <a:spcBef>
-                <a:spcPts val="0"/>
-              </a:spcBef>
-              <a:spcAft>
-                <a:spcPts val="0"/>
-              </a:spcAft>
-            </a:pPr>
-            <a:r>
-              <a:rPr sz="1050" b="1" i="0" lang="en-AU" spc="126" cap="all">
-                <a:solidFill>
-                  <a:srgbClr val="EA493F"/>
-                </a:solidFill>
-                <a:latin typeface="Inter"/>
-              </a:rPr>
-              <a:t>PIPELINES</a:t>
-            </a:r>
-          </a:p>
-        </p:txBody>
-      </p:sp>
-      <p:sp>
-        <p:nvSpPr>
-          <p:cNvPr id="12" name="TextBox 11"/>
-          <p:cNvSpPr txBox="1"/>
-          <p:nvPr/>
-        </p:nvSpPr>
-        <p:spPr>
-          <a:xfrm>
-            <a:off x="7863840" y="2313432"/>
-            <a:ext cx="3450031" cy="822960"/>
-          </a:xfrm>
-          <a:prstGeom prst="rect">
-            <a:avLst/>
-          </a:prstGeom>
-          <a:noFill/>
-        </p:spPr>
-        <p:txBody>
-          <a:bodyPr wrap="square" anchor="ctr" lIns="0" rIns="0" tIns="0" bIns="0"/>
-          <a:lstStyle/>
-          <a:p>
-            <a:pPr algn="l">
-              <a:lnSpc>
-                <a:spcPct val="118000"/>
-              </a:lnSpc>
-              <a:spcBef>
-                <a:spcPts val="0"/>
-              </a:spcBef>
-              <a:spcAft>
-                <a:spcPts val="0"/>
-              </a:spcAft>
-            </a:pPr>
-            <a:r>
-              <a:rPr sz="1300" b="0" i="0" lang="en-AU" spc="0">
+                <a:spcPct val="110000"/>
+              </a:lnSpc>
+              <a:spcBef>
+                <a:spcPts val="0"/>
+              </a:spcBef>
+              <a:spcAft>
+                <a:spcPts val="0"/>
+              </a:spcAft>
+            </a:pPr>
+            <a:r>
+              <a:rPr sz="1400" b="0" i="0" lang="en-AU" spc="-7">
                 <a:solidFill>
                   <a:srgbClr val="D6D6D6"/>
                 </a:solidFill>
@@ -6079,7 +5907,7 @@
               <a:t>Built </a:t>
             </a:r>
             <a:r>
-              <a:rPr sz="1300" b="1" i="0" lang="en-AU" spc="0">
+              <a:rPr sz="1400" b="1" i="0" lang="en-AU" spc="-7">
                 <a:solidFill>
                   <a:srgbClr val="FFFFFF"/>
                 </a:solidFill>
@@ -6088,7 +5916,7 @@
               <a:t>Delta Lake pipelines</a:t>
             </a:r>
             <a:r>
-              <a:rPr sz="1300" b="0" i="0" lang="en-AU" spc="0">
+              <a:rPr sz="1400" b="0" i="0" lang="en-AU" spc="-7">
                 <a:solidFill>
                   <a:srgbClr val="D6D6D6"/>
                 </a:solidFill>
@@ -6097,7 +5925,7 @@
               <a:t> — batch and streaming — on </a:t>
             </a:r>
             <a:r>
-              <a:rPr sz="1300" b="1" i="0" lang="en-AU" spc="0">
+              <a:rPr sz="1400" b="1" i="0" lang="en-AU" spc="-7">
                 <a:solidFill>
                   <a:srgbClr val="FFFFFF"/>
                 </a:solidFill>
@@ -6106,7 +5934,7 @@
               <a:t>Databricks</a:t>
             </a:r>
             <a:r>
-              <a:rPr sz="1300" b="0" i="0" lang="en-AU" spc="0">
+              <a:rPr sz="1400" b="0" i="0" lang="en-AU" spc="-7">
                 <a:solidFill>
                   <a:srgbClr val="D6D6D6"/>
                 </a:solidFill>
@@ -6119,13 +5947,13 @@
       </p:sp>
       <p:cxnSp>
         <p:nvCxnSpPr>
-          <p:cNvPr id="13" name="Connector 12"/>
+          <p:cNvPr id="12" name="Connector 11"/>
           <p:cNvCxnSpPr/>
           <p:nvPr/>
         </p:nvCxnSpPr>
         <p:spPr>
           <a:xfrm>
-            <a:off x="6355080" y="3172968"/>
+            <a:off x="6355080" y="3429000"/>
             <a:ext cx="4958791" cy="0"/>
           </a:xfrm>
           <a:prstGeom prst="bentConnector3">
@@ -6155,14 +5983,57 @@
       </p:cxnSp>
       <p:sp>
         <p:nvSpPr>
+          <p:cNvPr id="13" name="TextBox 12"/>
+          <p:cNvSpPr txBox="1"/>
+          <p:nvPr/>
+        </p:nvSpPr>
+        <p:spPr>
+          <a:xfrm>
+            <a:off x="6355080" y="3611880"/>
+            <a:ext cx="4958791" cy="292608"/>
+          </a:xfrm>
+          <a:prstGeom prst="rect">
+            <a:avLst/>
+          </a:prstGeom>
+          <a:noFill/>
+        </p:spPr>
+        <p:txBody>
+          <a:bodyPr wrap="square" anchor="t" lIns="0" rIns="0" tIns="0" bIns="0"/>
+          <a:lstStyle/>
+          <a:p>
+            <a:pPr algn="l">
+              <a:lnSpc>
+                <a:spcPct val="100000"/>
+              </a:lnSpc>
+              <a:spcBef>
+                <a:spcPts val="0"/>
+              </a:spcBef>
+              <a:spcAft>
+                <a:spcPts val="0"/>
+              </a:spcAft>
+            </a:pPr>
+            <a:r>
+              <a:rPr sz="1050" b="1" i="0" lang="en-AU" spc="147" cap="all">
+                <a:solidFill>
+                  <a:srgbClr val="EA493F"/>
+                </a:solidFill>
+                <a:latin typeface="Inter"/>
+              </a:rPr>
+              <a:t>INTEGRATION</a:t>
+            </a:r>
+          </a:p>
+        </p:txBody>
+      </p:sp>
+      <p:sp>
+        <p:nvSpPr>
           <p:cNvPr id="14" name="TextBox 13"/>
           <p:cNvSpPr txBox="1"/>
           <p:nvPr/>
         </p:nvSpPr>
         <p:spPr>
           <a:xfrm>
-            <a:off x="6355080" y="3319272"/>
-            <a:ext cx="1417320" cy="731520"/>
+            <a:off x="6355080" y="3922776"/>
+            <a:ext cx="4958791" cy="457200"/>
           </a:xfrm>
           <a:prstGeom prst="rect">
             <a:avLst/>
@@ -6175,60 +6046,17 @@
           <a:p>
             <a:pPr algn="l">
               <a:lnSpc>
-                <a:spcPct val="105000"/>
-              </a:lnSpc>
-              <a:spcBef>
-                <a:spcPts val="0"/>
-              </a:spcBef>
-              <a:spcAft>
-                <a:spcPts val="0"/>
-              </a:spcAft>
-            </a:pPr>
-            <a:r>
-              <a:rPr sz="1050" b="1" i="0" lang="en-AU" spc="126" cap="all">
-                <a:solidFill>
-                  <a:srgbClr val="EA493F"/>
-                </a:solidFill>
-                <a:latin typeface="Inter"/>
-              </a:rPr>
-              <a:t>INTEGRATION</a:t>
-            </a:r>
-          </a:p>
-        </p:txBody>
-      </p:sp>
-      <p:sp>
-        <p:nvSpPr>
-          <p:cNvPr id="15" name="TextBox 14"/>
-          <p:cNvSpPr txBox="1"/>
-          <p:nvPr/>
-        </p:nvSpPr>
-        <p:spPr>
-          <a:xfrm>
-            <a:off x="7863840" y="3282696"/>
-            <a:ext cx="3450031" cy="822960"/>
-          </a:xfrm>
-          <a:prstGeom prst="rect">
-            <a:avLst/>
-          </a:prstGeom>
-          <a:noFill/>
-        </p:spPr>
-        <p:txBody>
-          <a:bodyPr wrap="square" anchor="ctr" lIns="0" rIns="0" tIns="0" bIns="0"/>
-          <a:lstStyle/>
-          <a:p>
-            <a:pPr algn="l">
-              <a:lnSpc>
-                <a:spcPct val="118000"/>
-              </a:lnSpc>
-              <a:spcBef>
-                <a:spcPts val="0"/>
-              </a:spcBef>
-              <a:spcAft>
-                <a:spcPts val="0"/>
-              </a:spcAft>
-            </a:pPr>
-            <a:r>
-              <a:rPr sz="1300" b="0" i="0" lang="en-AU" spc="0">
+                <a:spcPct val="110000"/>
+              </a:lnSpc>
+              <a:spcBef>
+                <a:spcPts val="0"/>
+              </a:spcBef>
+              <a:spcAft>
+                <a:spcPts val="0"/>
+              </a:spcAft>
+            </a:pPr>
+            <a:r>
+              <a:rPr sz="1400" b="0" i="0" lang="en-AU" spc="-7">
                 <a:solidFill>
                   <a:srgbClr val="D6D6D6"/>
                 </a:solidFill>
@@ -6237,7 +6065,7 @@
               <a:t>Connected Databricks to </a:t>
             </a:r>
             <a:r>
-              <a:rPr sz="1300" b="1" i="0" lang="en-AU" spc="0">
+              <a:rPr sz="1400" b="1" i="0" lang="en-AU" spc="-7">
                 <a:solidFill>
                   <a:srgbClr val="FFFFFF"/>
                 </a:solidFill>
@@ -6246,7 +6074,7 @@
               <a:t>Workday, payroll and finance</a:t>
             </a:r>
             <a:r>
-              <a:rPr sz="1300" b="0" i="0" lang="en-AU" spc="0">
+              <a:rPr sz="1400" b="0" i="0" lang="en-AU" spc="-7">
                 <a:solidFill>
                   <a:srgbClr val="D6D6D6"/>
                 </a:solidFill>
@@ -6259,13 +6087,13 @@
       </p:sp>
       <p:cxnSp>
         <p:nvCxnSpPr>
-          <p:cNvPr id="16" name="Connector 15"/>
+          <p:cNvPr id="15" name="Connector 14"/>
           <p:cNvCxnSpPr/>
           <p:nvPr/>
         </p:nvCxnSpPr>
         <p:spPr>
           <a:xfrm>
-            <a:off x="6355080" y="4142232"/>
+            <a:off x="6355080" y="4526280"/>
             <a:ext cx="4958791" cy="0"/>
           </a:xfrm>
           <a:prstGeom prst="bentConnector3">
@@ -6295,14 +6123,57 @@
       </p:cxnSp>
       <p:sp>
         <p:nvSpPr>
+          <p:cNvPr id="16" name="TextBox 15"/>
+          <p:cNvSpPr txBox="1"/>
+          <p:nvPr/>
+        </p:nvSpPr>
+        <p:spPr>
+          <a:xfrm>
+            <a:off x="6355080" y="4709159"/>
+            <a:ext cx="4958791" cy="292608"/>
+          </a:xfrm>
+          <a:prstGeom prst="rect">
+            <a:avLst/>
+          </a:prstGeom>
+          <a:noFill/>
+        </p:spPr>
+        <p:txBody>
+          <a:bodyPr wrap="square" anchor="t" lIns="0" rIns="0" tIns="0" bIns="0"/>
+          <a:lstStyle/>
+          <a:p>
+            <a:pPr algn="l">
+              <a:lnSpc>
+                <a:spcPct val="100000"/>
+              </a:lnSpc>
+              <a:spcBef>
+                <a:spcPts val="0"/>
+              </a:spcBef>
+              <a:spcAft>
+                <a:spcPts val="0"/>
+              </a:spcAft>
+            </a:pPr>
+            <a:r>
+              <a:rPr sz="1050" b="1" i="0" lang="en-AU" spc="147" cap="all">
+                <a:solidFill>
+                  <a:srgbClr val="EA493F"/>
+                </a:solidFill>
+                <a:latin typeface="Inter"/>
+              </a:rPr>
+              <a:t>OUTCOME</a:t>
+            </a:r>
+          </a:p>
+        </p:txBody>
+      </p:sp>
+      <p:sp>
+        <p:nvSpPr>
           <p:cNvPr id="17" name="TextBox 16"/>
           <p:cNvSpPr txBox="1"/>
           <p:nvPr/>
         </p:nvSpPr>
         <p:spPr>
           <a:xfrm>
-            <a:off x="6355080" y="4288536"/>
-            <a:ext cx="1417320" cy="731520"/>
+            <a:off x="6355080" y="5020055"/>
+            <a:ext cx="4958791" cy="457200"/>
           </a:xfrm>
           <a:prstGeom prst="rect">
             <a:avLst/>
@@ -6315,60 +6186,17 @@
           <a:p>
             <a:pPr algn="l">
               <a:lnSpc>
-                <a:spcPct val="105000"/>
-              </a:lnSpc>
-              <a:spcBef>
-                <a:spcPts val="0"/>
-              </a:spcBef>
-              <a:spcAft>
-                <a:spcPts val="0"/>
-              </a:spcAft>
-            </a:pPr>
-            <a:r>
-              <a:rPr sz="1050" b="1" i="0" lang="en-AU" spc="126" cap="all">
-                <a:solidFill>
-                  <a:srgbClr val="EA493F"/>
-                </a:solidFill>
-                <a:latin typeface="Inter"/>
-              </a:rPr>
-              <a:t>OUTCOME</a:t>
-            </a:r>
-          </a:p>
-        </p:txBody>
-      </p:sp>
-      <p:sp>
-        <p:nvSpPr>
-          <p:cNvPr id="18" name="TextBox 17"/>
-          <p:cNvSpPr txBox="1"/>
-          <p:nvPr/>
-        </p:nvSpPr>
-        <p:spPr>
-          <a:xfrm>
-            <a:off x="7863840" y="4251960"/>
-            <a:ext cx="3450031" cy="822960"/>
-          </a:xfrm>
-          <a:prstGeom prst="rect">
-            <a:avLst/>
-          </a:prstGeom>
-          <a:noFill/>
-        </p:spPr>
-        <p:txBody>
-          <a:bodyPr wrap="square" anchor="ctr" lIns="0" rIns="0" tIns="0" bIns="0"/>
-          <a:lstStyle/>
-          <a:p>
-            <a:pPr algn="l">
-              <a:lnSpc>
-                <a:spcPct val="118000"/>
-              </a:lnSpc>
-              <a:spcBef>
-                <a:spcPts val="0"/>
-              </a:spcBef>
-              <a:spcAft>
-                <a:spcPts val="0"/>
-              </a:spcAft>
-            </a:pPr>
-            <a:r>
-              <a:rPr sz="1300" b="0" i="0" lang="en-AU" spc="0">
+                <a:spcPct val="110000"/>
+              </a:lnSpc>
+              <a:spcBef>
+                <a:spcPts val="0"/>
+              </a:spcBef>
+              <a:spcAft>
+                <a:spcPts val="0"/>
+              </a:spcAft>
+            </a:pPr>
+            <a:r>
+              <a:rPr sz="1400" b="0" i="0" lang="en-AU" spc="-7">
                 <a:solidFill>
                   <a:srgbClr val="D6D6D6"/>
                 </a:solidFill>
@@ -6377,7 +6205,7 @@
               <a:t>Delivered </a:t>
             </a:r>
             <a:r>
-              <a:rPr sz="1300" b="1" i="0" lang="en-AU" spc="0">
+              <a:rPr sz="1400" b="1" i="0" lang="en-AU" spc="-7">
                 <a:solidFill>
                   <a:srgbClr val="FFFFFF"/>
                 </a:solidFill>
@@ -6386,7 +6214,7 @@
               <a:t>governed KPI stores</a:t>
             </a:r>
             <a:r>
-              <a:rPr sz="1300" b="0" i="0" lang="en-AU" spc="0">
+              <a:rPr sz="1400" b="0" i="0" lang="en-AU" spc="-7">
                 <a:solidFill>
                   <a:srgbClr val="D6D6D6"/>
                 </a:solidFill>
@@ -6395,7 +6223,7 @@
               <a:t> and </a:t>
             </a:r>
             <a:r>
-              <a:rPr sz="1300" b="1" i="0" lang="en-AU" spc="0">
+              <a:rPr sz="1400" b="1" i="0" lang="en-AU" spc="-7">
                 <a:solidFill>
                   <a:srgbClr val="FFFFFF"/>
                 </a:solidFill>
@@ -6404,7 +6232,7 @@
               <a:t>real-time insight</a:t>
             </a:r>
             <a:r>
-              <a:rPr sz="1300" b="0" i="0" lang="en-AU" spc="0">
+              <a:rPr sz="1400" b="0" i="0" lang="en-AU" spc="-7">
                 <a:solidFill>
                   <a:srgbClr val="D6D6D6"/>
                 </a:solidFill>
@@ -6417,13 +6245,13 @@
       </p:sp>
       <p:cxnSp>
         <p:nvCxnSpPr>
-          <p:cNvPr id="19" name="Connector 18"/>
+          <p:cNvPr id="18" name="Connector 17"/>
           <p:cNvCxnSpPr/>
           <p:nvPr/>
         </p:nvCxnSpPr>
         <p:spPr>
           <a:xfrm>
-            <a:off x="6355080" y="5111496"/>
+            <a:off x="6355080" y="5623559"/>
             <a:ext cx="4958791" cy="0"/>
           </a:xfrm>
           <a:prstGeom prst="bentConnector3">
@@ -6533,9 +6361,9 @@
               </a:spcAft>
             </a:pPr>
             <a:r>
-              <a:rPr sz="1050" b="1" i="0" lang="en-AU" spc="147" cap="all">
-                <a:solidFill>
-                  <a:srgbClr val="AEAEAE"/>
+              <a:rPr sz="1100" b="1" i="0" lang="en-AU" spc="154" cap="all">
+                <a:solidFill>
+                  <a:srgbClr val="EA493F"/>
                 </a:solidFill>
                 <a:latin typeface="Inter"/>
               </a:rPr>
@@ -6546,50 +6374,7 @@
       </p:sp>
       <p:sp>
         <p:nvSpPr>
-          <p:cNvPr id="4" name="TextBox 3"/>
-          <p:cNvSpPr txBox="1"/>
-          <p:nvPr/>
-        </p:nvSpPr>
-        <p:spPr>
-          <a:xfrm>
-            <a:off x="877824" y="841248"/>
-            <a:ext cx="7315200" cy="320040"/>
-          </a:xfrm>
-          <a:prstGeom prst="rect">
-            <a:avLst/>
-          </a:prstGeom>
-          <a:noFill/>
-        </p:spPr>
-        <p:txBody>
-          <a:bodyPr wrap="square" anchor="t" lIns="0" rIns="0" tIns="0" bIns="0"/>
-          <a:lstStyle/>
-          <a:p>
-            <a:pPr algn="l">
-              <a:lnSpc>
-                <a:spcPct val="100000"/>
-              </a:lnSpc>
-              <a:spcBef>
-                <a:spcPts val="0"/>
-              </a:spcBef>
-              <a:spcAft>
-                <a:spcPts val="0"/>
-              </a:spcAft>
-            </a:pPr>
-            <a:r>
-              <a:rPr sz="1200" b="1" i="0" lang="en-AU" spc="192" cap="all">
-                <a:solidFill>
-                  <a:srgbClr val="EA493F"/>
-                </a:solidFill>
-                <a:latin typeface="Inter"/>
-              </a:rPr>
-              <a:t>IN THEIR WORDS</a:t>
-            </a:r>
-          </a:p>
-        </p:txBody>
-      </p:sp>
-      <p:sp>
-        <p:nvSpPr>
-          <p:cNvPr id="5" name="Rectangle 4"/>
+          <p:cNvPr id="4" name="Rectangle 3"/>
           <p:cNvSpPr/>
           <p:nvPr/>
         </p:nvSpPr>
@@ -6633,55 +6418,55 @@
       </p:sp>
       <p:sp>
         <p:nvSpPr>
+          <p:cNvPr id="5" name="TextBox 4"/>
+          <p:cNvSpPr txBox="1"/>
+          <p:nvPr/>
+        </p:nvSpPr>
+        <p:spPr>
+          <a:xfrm>
+            <a:off x="1207008" y="1371600"/>
+            <a:ext cx="9601200" cy="2468880"/>
+          </a:xfrm>
+          <a:prstGeom prst="rect">
+            <a:avLst/>
+          </a:prstGeom>
+          <a:noFill/>
+        </p:spPr>
+        <p:txBody>
+          <a:bodyPr wrap="square" anchor="t" lIns="0" rIns="0" tIns="0" bIns="0"/>
+          <a:lstStyle/>
+          <a:p>
+            <a:pPr algn="l">
+              <a:lnSpc>
+                <a:spcPct val="106000"/>
+              </a:lnSpc>
+              <a:spcBef>
+                <a:spcPts val="0"/>
+              </a:spcBef>
+              <a:spcAft>
+                <a:spcPts val="0"/>
+              </a:spcAft>
+            </a:pPr>
+            <a:r>
+              <a:rPr sz="3800" b="1" i="0" lang="en-AU" spc="-76">
+                <a:solidFill>
+                  <a:srgbClr val="EA493F"/>
+                </a:solidFill>
+                <a:latin typeface="Inter"/>
+              </a:rPr>
+              <a:t>“They delivered in weeks what we'd scoped for a year — and our team actually uses it.”</a:t>
+            </a:r>
+          </a:p>
+        </p:txBody>
+      </p:sp>
+      <p:sp>
+        <p:nvSpPr>
           <p:cNvPr id="6" name="TextBox 5"/>
           <p:cNvSpPr txBox="1"/>
           <p:nvPr/>
         </p:nvSpPr>
         <p:spPr>
           <a:xfrm>
-            <a:off x="1207008" y="1371600"/>
-            <a:ext cx="9601200" cy="2468880"/>
-          </a:xfrm>
-          <a:prstGeom prst="rect">
-            <a:avLst/>
-          </a:prstGeom>
-          <a:noFill/>
-        </p:spPr>
-        <p:txBody>
-          <a:bodyPr wrap="square" anchor="t" lIns="0" rIns="0" tIns="0" bIns="0"/>
-          <a:lstStyle/>
-          <a:p>
-            <a:pPr algn="l">
-              <a:lnSpc>
-                <a:spcPct val="106000"/>
-              </a:lnSpc>
-              <a:spcBef>
-                <a:spcPts val="0"/>
-              </a:spcBef>
-              <a:spcAft>
-                <a:spcPts val="0"/>
-              </a:spcAft>
-            </a:pPr>
-            <a:r>
-              <a:rPr sz="3800" b="1" i="0" lang="en-AU" spc="-76">
-                <a:solidFill>
-                  <a:srgbClr val="EA493F"/>
-                </a:solidFill>
-                <a:latin typeface="Inter"/>
-              </a:rPr>
-              <a:t>“They delivered in weeks what we'd scoped for a year — and our team actually uses it.”</a:t>
-            </a:r>
-          </a:p>
-        </p:txBody>
-      </p:sp>
-      <p:sp>
-        <p:nvSpPr>
-          <p:cNvPr id="7" name="TextBox 6"/>
-          <p:cNvSpPr txBox="1"/>
-          <p:nvPr/>
-        </p:nvSpPr>
-        <p:spPr>
-          <a:xfrm>
             <a:off x="1207008" y="3822191"/>
             <a:ext cx="9144000" cy="365760"/>
           </a:xfrm>
@@ -6719,7 +6504,7 @@
       </p:sp>
       <p:cxnSp>
         <p:nvCxnSpPr>
-          <p:cNvPr id="8" name="Connector 7"/>
+          <p:cNvPr id="7" name="Connector 6"/>
           <p:cNvCxnSpPr/>
           <p:nvPr/>
         </p:nvCxnSpPr>
@@ -6755,64 +6540,64 @@
       </p:cxnSp>
       <p:sp>
         <p:nvSpPr>
+          <p:cNvPr id="8" name="TextBox 7"/>
+          <p:cNvSpPr txBox="1"/>
+          <p:nvPr/>
+        </p:nvSpPr>
+        <p:spPr>
+          <a:xfrm>
+            <a:off x="877824" y="4892040"/>
+            <a:ext cx="3314090" cy="1051560"/>
+          </a:xfrm>
+          <a:prstGeom prst="rect">
+            <a:avLst/>
+          </a:prstGeom>
+          <a:noFill/>
+        </p:spPr>
+        <p:txBody>
+          <a:bodyPr wrap="square" anchor="b" lIns="0" rIns="0" tIns="0" bIns="0"/>
+          <a:lstStyle/>
+          <a:p>
+            <a:pPr algn="l">
+              <a:lnSpc>
+                <a:spcPct val="92000"/>
+              </a:lnSpc>
+              <a:spcBef>
+                <a:spcPts val="0"/>
+              </a:spcBef>
+              <a:spcAft>
+                <a:spcPts val="0"/>
+              </a:spcAft>
+            </a:pPr>
+            <a:r>
+              <a:rPr sz="5800" b="1" i="0" lang="en-AU" spc="-203">
+                <a:solidFill>
+                  <a:srgbClr val="111111"/>
+                </a:solidFill>
+                <a:latin typeface="Inter"/>
+              </a:rPr>
+              <a:t>40</a:t>
+            </a:r>
+            <a:r>
+              <a:rPr sz="5800" b="1" i="0" lang="en-AU" spc="-203">
+                <a:solidFill>
+                  <a:srgbClr val="EA493F"/>
+                </a:solidFill>
+                <a:latin typeface="Inter"/>
+              </a:rPr>
+              <a:t>+</a:t>
+            </a:r>
+          </a:p>
+        </p:txBody>
+      </p:sp>
+      <p:sp>
+        <p:nvSpPr>
           <p:cNvPr id="9" name="TextBox 8"/>
           <p:cNvSpPr txBox="1"/>
           <p:nvPr/>
         </p:nvSpPr>
         <p:spPr>
           <a:xfrm>
-            <a:off x="877824" y="4892040"/>
-            <a:ext cx="3314090" cy="1051560"/>
-          </a:xfrm>
-          <a:prstGeom prst="rect">
-            <a:avLst/>
-          </a:prstGeom>
-          <a:noFill/>
-        </p:spPr>
-        <p:txBody>
-          <a:bodyPr wrap="square" anchor="b" lIns="0" rIns="0" tIns="0" bIns="0"/>
-          <a:lstStyle/>
-          <a:p>
-            <a:pPr algn="l">
-              <a:lnSpc>
-                <a:spcPct val="92000"/>
-              </a:lnSpc>
-              <a:spcBef>
-                <a:spcPts val="0"/>
-              </a:spcBef>
-              <a:spcAft>
-                <a:spcPts val="0"/>
-              </a:spcAft>
-            </a:pPr>
-            <a:r>
-              <a:rPr sz="5800" b="1" i="0" lang="en-AU" spc="-203">
-                <a:solidFill>
-                  <a:srgbClr val="111111"/>
-                </a:solidFill>
-                <a:latin typeface="Inter"/>
-              </a:rPr>
-              <a:t>40</a:t>
-            </a:r>
-            <a:r>
-              <a:rPr sz="5800" b="1" i="0" lang="en-AU" spc="-203">
-                <a:solidFill>
-                  <a:srgbClr val="EA493F"/>
-                </a:solidFill>
-                <a:latin typeface="Inter"/>
-              </a:rPr>
-              <a:t>+</a:t>
-            </a:r>
-          </a:p>
-        </p:txBody>
-      </p:sp>
-      <p:sp>
-        <p:nvSpPr>
-          <p:cNvPr id="10" name="TextBox 9"/>
-          <p:cNvSpPr txBox="1"/>
-          <p:nvPr/>
-        </p:nvSpPr>
-        <p:spPr>
-          <a:xfrm>
             <a:off x="877824" y="6025896"/>
             <a:ext cx="3250082" cy="640080"/>
           </a:xfrm>
@@ -6850,7 +6635,7 @@
       </p:sp>
       <p:cxnSp>
         <p:nvCxnSpPr>
-          <p:cNvPr id="11" name="Connector 10"/>
+          <p:cNvPr id="10" name="Connector 9"/>
           <p:cNvCxnSpPr/>
           <p:nvPr/>
         </p:nvCxnSpPr>
@@ -6886,64 +6671,64 @@
       </p:cxnSp>
       <p:sp>
         <p:nvSpPr>
+          <p:cNvPr id="11" name="TextBox 10"/>
+          <p:cNvSpPr txBox="1"/>
+          <p:nvPr/>
+        </p:nvSpPr>
+        <p:spPr>
+          <a:xfrm>
+            <a:off x="4667402" y="4892040"/>
+            <a:ext cx="3003194" cy="1051560"/>
+          </a:xfrm>
+          <a:prstGeom prst="rect">
+            <a:avLst/>
+          </a:prstGeom>
+          <a:noFill/>
+        </p:spPr>
+        <p:txBody>
+          <a:bodyPr wrap="square" anchor="b" lIns="0" rIns="0" tIns="0" bIns="0"/>
+          <a:lstStyle/>
+          <a:p>
+            <a:pPr algn="l">
+              <a:lnSpc>
+                <a:spcPct val="92000"/>
+              </a:lnSpc>
+              <a:spcBef>
+                <a:spcPts val="0"/>
+              </a:spcBef>
+              <a:spcAft>
+                <a:spcPts val="0"/>
+              </a:spcAft>
+            </a:pPr>
+            <a:r>
+              <a:rPr sz="5800" b="1" i="0" lang="en-AU" spc="-203">
+                <a:solidFill>
+                  <a:srgbClr val="111111"/>
+                </a:solidFill>
+                <a:latin typeface="Inter"/>
+              </a:rPr>
+              <a:t>98</a:t>
+            </a:r>
+            <a:r>
+              <a:rPr sz="5800" b="1" i="0" lang="en-AU" spc="-203">
+                <a:solidFill>
+                  <a:srgbClr val="EA493F"/>
+                </a:solidFill>
+                <a:latin typeface="Inter"/>
+              </a:rPr>
+              <a:t>%</a:t>
+            </a:r>
+          </a:p>
+        </p:txBody>
+      </p:sp>
+      <p:sp>
+        <p:nvSpPr>
           <p:cNvPr id="12" name="TextBox 11"/>
           <p:cNvSpPr txBox="1"/>
           <p:nvPr/>
         </p:nvSpPr>
         <p:spPr>
           <a:xfrm>
-            <a:off x="4667402" y="4892040"/>
-            <a:ext cx="3003194" cy="1051560"/>
-          </a:xfrm>
-          <a:prstGeom prst="rect">
-            <a:avLst/>
-          </a:prstGeom>
-          <a:noFill/>
-        </p:spPr>
-        <p:txBody>
-          <a:bodyPr wrap="square" anchor="b" lIns="0" rIns="0" tIns="0" bIns="0"/>
-          <a:lstStyle/>
-          <a:p>
-            <a:pPr algn="l">
-              <a:lnSpc>
-                <a:spcPct val="92000"/>
-              </a:lnSpc>
-              <a:spcBef>
-                <a:spcPts val="0"/>
-              </a:spcBef>
-              <a:spcAft>
-                <a:spcPts val="0"/>
-              </a:spcAft>
-            </a:pPr>
-            <a:r>
-              <a:rPr sz="5800" b="1" i="0" lang="en-AU" spc="-203">
-                <a:solidFill>
-                  <a:srgbClr val="111111"/>
-                </a:solidFill>
-                <a:latin typeface="Inter"/>
-              </a:rPr>
-              <a:t>98</a:t>
-            </a:r>
-            <a:r>
-              <a:rPr sz="5800" b="1" i="0" lang="en-AU" spc="-203">
-                <a:solidFill>
-                  <a:srgbClr val="EA493F"/>
-                </a:solidFill>
-                <a:latin typeface="Inter"/>
-              </a:rPr>
-              <a:t>%</a:t>
-            </a:r>
-          </a:p>
-        </p:txBody>
-      </p:sp>
-      <p:sp>
-        <p:nvSpPr>
-          <p:cNvPr id="13" name="TextBox 12"/>
-          <p:cNvSpPr txBox="1"/>
-          <p:nvPr/>
-        </p:nvSpPr>
-        <p:spPr>
-          <a:xfrm>
             <a:off x="4667402" y="6025896"/>
             <a:ext cx="2939186" cy="640080"/>
           </a:xfrm>
@@ -6981,7 +6766,7 @@
       </p:sp>
       <p:cxnSp>
         <p:nvCxnSpPr>
-          <p:cNvPr id="14" name="Connector 13"/>
+          <p:cNvPr id="13" name="Connector 12"/>
           <p:cNvCxnSpPr/>
           <p:nvPr/>
         </p:nvCxnSpPr>
@@ -7017,7 +6802,7 @@
       </p:cxnSp>
       <p:sp>
         <p:nvSpPr>
-          <p:cNvPr id="15" name="TextBox 14"/>
+          <p:cNvPr id="14" name="TextBox 13"/>
           <p:cNvSpPr txBox="1"/>
           <p:nvPr/>
         </p:nvSpPr>
@@ -7060,7 +6845,7 @@
       </p:sp>
       <p:sp>
         <p:nvSpPr>
-          <p:cNvPr id="16" name="TextBox 15"/>
+          <p:cNvPr id="15" name="TextBox 14"/>
           <p:cNvSpPr txBox="1"/>
           <p:nvPr/>
         </p:nvSpPr>
@@ -7183,9 +6968,9 @@
               </a:spcAft>
             </a:pPr>
             <a:r>
-              <a:rPr sz="1050" b="1" i="0" lang="en-AU" spc="147" cap="all">
-                <a:solidFill>
-                  <a:srgbClr val="777777"/>
+              <a:rPr sz="1100" b="1" i="0" lang="en-AU" spc="154" cap="all">
+                <a:solidFill>
+                  <a:srgbClr val="EA493F"/>
                 </a:solidFill>
                 <a:latin typeface="Inter"/>
               </a:rPr>
@@ -7202,8 +6987,8 @@
         </p:nvSpPr>
         <p:spPr>
           <a:xfrm>
-            <a:off x="877824" y="841248"/>
-            <a:ext cx="7315200" cy="320040"/>
+            <a:off x="841248" y="914400"/>
+            <a:ext cx="10058400" cy="1005840"/>
           </a:xfrm>
           <a:prstGeom prst="rect">
             <a:avLst/>
@@ -7226,13 +7011,22 @@
               </a:spcAft>
             </a:pPr>
             <a:r>
-              <a:rPr sz="1200" b="1" i="0" lang="en-AU" spc="192" cap="all">
+              <a:rPr sz="3400" b="1" i="0" lang="en-AU" spc="-74">
+                <a:solidFill>
+                  <a:srgbClr val="FFFFFF"/>
+                </a:solidFill>
+                <a:latin typeface="Inter"/>
+              </a:rPr>
+              <a:t>Why teams choose to </a:t>
+            </a:r>
+            <a:r>
+              <a:rPr sz="3400" b="1" i="0" lang="en-AU" spc="-74">
                 <a:solidFill>
                   <a:srgbClr val="EA493F"/>
                 </a:solidFill>
                 <a:latin typeface="Inter"/>
               </a:rPr>
-              <a:t>THREE REASONS</a:t>
+              <a:t>stay with us.</a:t>
             </a:r>
           </a:p>
         </p:txBody>
@@ -7245,58 +7039,6 @@
         </p:nvSpPr>
         <p:spPr>
           <a:xfrm>
-            <a:off x="841248" y="1225296"/>
-            <a:ext cx="10058400" cy="1005840"/>
-          </a:xfrm>
-          <a:prstGeom prst="rect">
-            <a:avLst/>
-          </a:prstGeom>
-          <a:noFill/>
-        </p:spPr>
-        <p:txBody>
-          <a:bodyPr wrap="square" anchor="t" lIns="0" rIns="0" tIns="0" bIns="0"/>
-          <a:lstStyle/>
-          <a:p>
-            <a:pPr algn="l">
-              <a:lnSpc>
-                <a:spcPct val="100000"/>
-              </a:lnSpc>
-              <a:spcBef>
-                <a:spcPts val="0"/>
-              </a:spcBef>
-              <a:spcAft>
-                <a:spcPts val="0"/>
-              </a:spcAft>
-            </a:pPr>
-            <a:r>
-              <a:rPr sz="3400" b="1" i="0" lang="en-AU" spc="-74">
-                <a:solidFill>
-                  <a:srgbClr val="FFFFFF"/>
-                </a:solidFill>
-                <a:latin typeface="Inter"/>
-              </a:rPr>
-              <a:t>Why teams choose to </a:t>
-            </a:r>
-            <a:r>
-              <a:rPr sz="3400" b="1" i="0" lang="en-AU" spc="-74">
-                <a:solidFill>
-                  <a:srgbClr val="EA493F"/>
-                </a:solidFill>
-                <a:latin typeface="Inter"/>
-              </a:rPr>
-              <a:t>stay with us.</a:t>
-            </a:r>
-          </a:p>
-        </p:txBody>
-      </p:sp>
-      <p:sp>
-        <p:nvSpPr>
-          <p:cNvPr id="6" name="TextBox 5"/>
-          <p:cNvSpPr txBox="1"/>
-          <p:nvPr/>
-        </p:nvSpPr>
-        <p:spPr>
-          <a:xfrm>
             <a:off x="877824" y="2971800"/>
             <a:ext cx="3204362" cy="2377440"/>
           </a:xfrm>
@@ -7378,7 +7120,7 @@
       </p:sp>
       <p:cxnSp>
         <p:nvCxnSpPr>
-          <p:cNvPr id="7" name="Connector 6"/>
+          <p:cNvPr id="6" name="Connector 5"/>
           <p:cNvCxnSpPr/>
           <p:nvPr/>
         </p:nvCxnSpPr>
@@ -7414,7 +7156,7 @@
       </p:cxnSp>
       <p:sp>
         <p:nvSpPr>
-          <p:cNvPr id="8" name="TextBox 7"/>
+          <p:cNvPr id="7" name="TextBox 6"/>
           <p:cNvSpPr txBox="1"/>
           <p:nvPr/>
         </p:nvSpPr>
@@ -7501,7 +7243,7 @@
       </p:sp>
       <p:cxnSp>
         <p:nvCxnSpPr>
-          <p:cNvPr id="9" name="Connector 8"/>
+          <p:cNvPr id="8" name="Connector 7"/>
           <p:cNvCxnSpPr/>
           <p:nvPr/>
         </p:nvCxnSpPr>
@@ -7537,7 +7279,7 @@
       </p:cxnSp>
       <p:sp>
         <p:nvSpPr>
-          <p:cNvPr id="10" name="TextBox 9"/>
+          <p:cNvPr id="9" name="TextBox 8"/>
           <p:cNvSpPr txBox="1"/>
           <p:nvPr/>
         </p:nvSpPr>

</xml_diff>

<commit_message>
Merge overview + AMS into one deck; de-number section labels
- mivada_full_deck.py -> Mivada_Overview_and_Services.pptx (17 slides): company
  overview + AMS/services pack as one presentation.
- Section labels de-numbered (position-independent) so they read correctly in any
  order — the single coral top-right slug ("DATA & AI", not "05 · DATA & AI").
- Regenerated editorial.pptx, overview and AMS pptx to match.

https://claude.ai/code/session_018CuPeTbPKyC5roqRrfQGYh
</commit_message>
<xml_diff>
--- a/design-system/02-editorial/editorial.pptx
+++ b/design-system/02-editorial/editorial.pptx
@@ -3454,7 +3454,7 @@
                 </a:solidFill>
                 <a:latin typeface="Inter"/>
               </a:rPr>
-              <a:t>02 · WHO WE ARE</a:t>
+              <a:t>WHO WE ARE</a:t>
             </a:r>
           </a:p>
         </p:txBody>
@@ -4017,7 +4017,7 @@
                 </a:solidFill>
                 <a:latin typeface="Inter"/>
               </a:rPr>
-              <a:t>03 · WHAT WE DO</a:t>
+              <a:t>WHAT WE DO</a:t>
             </a:r>
           </a:p>
         </p:txBody>
@@ -4946,7 +4946,7 @@
                 </a:solidFill>
                 <a:latin typeface="Inter"/>
               </a:rPr>
-              <a:t>04 · HOW WE WORK</a:t>
+              <a:t>HOW WE WORK</a:t>
             </a:r>
           </a:p>
         </p:txBody>
@@ -5547,7 +5547,7 @@
                 </a:solidFill>
                 <a:latin typeface="Inter"/>
               </a:rPr>
-              <a:t>05 · DATA &amp; AI</a:t>
+              <a:t>DATA &amp; AI</a:t>
             </a:r>
           </a:p>
         </p:txBody>
@@ -6367,7 +6367,7 @@
                 </a:solidFill>
                 <a:latin typeface="Inter"/>
               </a:rPr>
-              <a:t>06 · OUTCOMES</a:t>
+              <a:t>OUTCOMES</a:t>
             </a:r>
           </a:p>
         </p:txBody>
@@ -6974,7 +6974,7 @@
                 </a:solidFill>
                 <a:latin typeface="Inter"/>
               </a:rPr>
-              <a:t>07 · WHY MIVADA</a:t>
+              <a:t>WHY MIVADA</a:t>
             </a:r>
           </a:p>
         </p:txBody>

</xml_diff>